<commit_message>
fix Symbol MT in lectures; draft AI-use policy
</commit_message>
<xml_diff>
--- a/docs/lectures/03-Twoway1.pptx
+++ b/docs/lectures/03-Twoway1.pptx
@@ -1,5 +1,958 @@
 
-<file path=ppt/presentation.xml><?xml version="1.0" encoding="utf-8"?>
+<file path=docProps\app.xml><?xml version="1.0" encoding="utf-8"?>
+<Properties xmlns="http://schemas.openxmlformats.org/officeDocument/2006/extended-properties" xmlns:vt="http://schemas.openxmlformats.org/officeDocument/2006/docPropsVTypes">
+  <Template/>
+  <TotalTime>7266</TotalTime>
+  <Words>5637</Words>
+  <Application>Microsoft Office PowerPoint</Application>
+  <PresentationFormat>On-screen Show (4:3)</PresentationFormat>
+  <Paragraphs>790</Paragraphs>
+  <Slides>76</Slides>
+  <Notes>3</Notes>
+  <HiddenSlides>0</HiddenSlides>
+  <MMClips>0</MMClips>
+  <ScaleCrop>false</ScaleCrop>
+  <HeadingPairs>
+    <vt:vector size="8" baseType="variant">
+      <vt:variant>
+        <vt:lpstr>Fonts Used</vt:lpstr>
+      </vt:variant>
+      <vt:variant>
+        <vt:i4>8</vt:i4>
+      </vt:variant>
+      <vt:variant>
+        <vt:lpstr>Theme</vt:lpstr>
+      </vt:variant>
+      <vt:variant>
+        <vt:i4>1</vt:i4>
+      </vt:variant>
+      <vt:variant>
+        <vt:lpstr>Embedded OLE Servers</vt:lpstr>
+      </vt:variant>
+      <vt:variant>
+        <vt:i4>1</vt:i4>
+      </vt:variant>
+      <vt:variant>
+        <vt:lpstr>Slide Titles</vt:lpstr>
+      </vt:variant>
+      <vt:variant>
+        <vt:i4>76</vt:i4>
+      </vt:variant>
+    </vt:vector>
+  </HeadingPairs>
+  <TitlesOfParts>
+    <vt:vector size="86" baseType="lpstr">
+      <vt:lpstr>Arial</vt:lpstr>
+      <vt:lpstr>Symbol</vt:lpstr>
+      <vt:lpstr>Calibri</vt:lpstr>
+      <vt:lpstr>Cambria Math</vt:lpstr>
+      <vt:lpstr>Symbol</vt:lpstr>
+      <vt:lpstr>Noto Music</vt:lpstr>
+      <vt:lpstr>Wingdings</vt:lpstr>
+      <vt:lpstr>Courier New</vt:lpstr>
+      <vt:lpstr>1_Office Theme</vt:lpstr>
+      <vt:lpstr>Equation</vt:lpstr>
+      <vt:lpstr>Two-way tables Independence &amp; association</vt:lpstr>
+      <vt:lpstr>Two-way tables: Overview</vt:lpstr>
+      <vt:lpstr>Methods</vt:lpstr>
+      <vt:lpstr>2 × 2 Example: Berkeley admissions</vt:lpstr>
+      <vt:lpstr>UCBAdmissions data</vt:lpstr>
+      <vt:lpstr>PowerPoint Presentation</vt:lpstr>
+      <vt:lpstr>Table notation: nij, πij, pij</vt:lpstr>
+      <vt:lpstr>r × c Example: Hair color, eye color</vt:lpstr>
+      <vt:lpstr>HairEyeColor data</vt:lpstr>
+      <vt:lpstr>Measures of association</vt:lpstr>
+      <vt:lpstr>Measures of association</vt:lpstr>
+      <vt:lpstr>Example: Bartlett data</vt:lpstr>
+      <vt:lpstr>Simple plots for r × c tables</vt:lpstr>
+      <vt:lpstr>Ordered tables</vt:lpstr>
+      <vt:lpstr>Mental data: Association</vt:lpstr>
+      <vt:lpstr>Mental data: Ordinal tests</vt:lpstr>
+      <vt:lpstr>Independence</vt:lpstr>
+      <vt:lpstr>Independence: Example</vt:lpstr>
+      <vt:lpstr>Independence: Example</vt:lpstr>
+      <vt:lpstr>Independence?: Arthritis data</vt:lpstr>
+      <vt:lpstr>Independence?: Arthritis data</vt:lpstr>
+      <vt:lpstr>Sampling models: Poisson, Binomial, Multinomial</vt:lpstr>
+      <vt:lpstr>Odds and log(Odds)</vt:lpstr>
+      <vt:lpstr>Log odds</vt:lpstr>
+      <vt:lpstr>Odds ratio</vt:lpstr>
+      <vt:lpstr>Odds ratio: Inference &amp; hypothesis tests</vt:lpstr>
+      <vt:lpstr>Odds ratio: Confidence intervals</vt:lpstr>
+      <vt:lpstr>Small sample size</vt:lpstr>
+      <vt:lpstr>Small sample size</vt:lpstr>
+      <vt:lpstr>Small sample size: Simulation</vt:lpstr>
+      <vt:lpstr>Small sample size: Fisher exact test</vt:lpstr>
+      <vt:lpstr>Visualizing association</vt:lpstr>
+      <vt:lpstr>Visualizing: fourfold plots</vt:lpstr>
+      <vt:lpstr>Visualizing: fourfold plots</vt:lpstr>
+      <vt:lpstr>Cholesterol data</vt:lpstr>
+      <vt:lpstr>Stratified tables: 2 × 2 × k</vt:lpstr>
+      <vt:lpstr>Odds ratios by department</vt:lpstr>
+      <vt:lpstr>Stratified fourfold plots</vt:lpstr>
+      <vt:lpstr>Log odds ratio plot</vt:lpstr>
+      <vt:lpstr>Fungicide data: 2 x 2 x 2 x 2</vt:lpstr>
+      <vt:lpstr>Stratified tables: Homogeneity of association</vt:lpstr>
+      <vt:lpstr>What happened at UC Berkeley?</vt:lpstr>
+      <vt:lpstr>Mosaic matrices</vt:lpstr>
+      <vt:lpstr>r × c tables: Overall analysis</vt:lpstr>
+      <vt:lpstr>r × c tables: Overall analysis</vt:lpstr>
+      <vt:lpstr>PowerPoint Presentation</vt:lpstr>
+      <vt:lpstr>Plots for two-way tables</vt:lpstr>
+      <vt:lpstr>Spine plots</vt:lpstr>
+      <vt:lpstr>Tile plots</vt:lpstr>
+      <vt:lpstr>Sieve diagrams</vt:lpstr>
+      <vt:lpstr>Sieve diagrams</vt:lpstr>
+      <vt:lpstr>Sieve diagrams: Effect ordering</vt:lpstr>
+      <vt:lpstr>Sieve diagrams: Subtle patterns</vt:lpstr>
+      <vt:lpstr>Ordinal factors</vt:lpstr>
+      <vt:lpstr>CMH tests for ordinal factors</vt:lpstr>
+      <vt:lpstr>Sample CMH profiles</vt:lpstr>
+      <vt:lpstr>Sample CMH profiles</vt:lpstr>
+      <vt:lpstr>Visualizing the association</vt:lpstr>
+      <vt:lpstr>Example: Mental health data</vt:lpstr>
+      <vt:lpstr>Observer agreement</vt:lpstr>
+      <vt:lpstr>Cohen’s κ</vt:lpstr>
+      <vt:lpstr>Example: Cohen’s κ </vt:lpstr>
+      <vt:lpstr>Example: Cohen’s κ </vt:lpstr>
+      <vt:lpstr>Observer agreement: Multiple strata</vt:lpstr>
+      <vt:lpstr>Observer agreement: Multiple strata</vt:lpstr>
+      <vt:lpstr>Bangdiwala’s Observer agreement chart</vt:lpstr>
+      <vt:lpstr>Bangdiwala’s Observer agreement chart</vt:lpstr>
+      <vt:lpstr>Weighted agreement chart: Partial agreement</vt:lpstr>
+      <vt:lpstr>PowerPoint Presentation</vt:lpstr>
+      <vt:lpstr>Marginal homogeneity &amp; observer bias</vt:lpstr>
+      <vt:lpstr>Looking ahead: Correspondence analysis</vt:lpstr>
+      <vt:lpstr>Looking ahead: Correspondence analysis</vt:lpstr>
+      <vt:lpstr>Looking ahead: Models</vt:lpstr>
+      <vt:lpstr>Looking ahead: Models</vt:lpstr>
+      <vt:lpstr>Looking ahead: Mosaic plots</vt:lpstr>
+      <vt:lpstr>Summary</vt:lpstr>
+    </vt:vector>
+  </TitlesOfParts>
+  <Company>YORK UNIVERSITY</Company>
+  <LinksUpToDate>false</LinksUpToDate>
+  <SharedDoc>false</SharedDoc>
+  <HyperlinksChanged>false</HyperlinksChanged>
+  <AppVersion>16.0000</AppVersion>
+</Properties>
+</file>
+
+<file path=docProps\core.xml><?xml version="1.0" encoding="utf-8"?>
+<cp:coreProperties xmlns:cp="http://schemas.openxmlformats.org/package/2006/metadata/core-properties" xmlns:dc="http://purl.org/dc/elements/1.1/" xmlns:dcterms="http://purl.org/dc/terms/" xmlns:dcmitype="http://purl.org/dc/dcmitype/" xmlns:xsi="http://www.w3.org/2001/XMLSchema-instance">
+  <dc:title>03-Twoway1</dc:title>
+  <dc:creator>Michael Friendly</dc:creator>
+  <cp:lastModifiedBy>Michael L Friendly</cp:lastModifiedBy>
+  <cp:revision>155</cp:revision>
+  <dcterms:created xsi:type="dcterms:W3CDTF">2017-10-14T20:35:56Z</dcterms:created>
+  <dcterms:modified xsi:type="dcterms:W3CDTF">2025-12-17T15:04:27Z</dcterms:modified>
+</cp:coreProperties>
+</file>
+
+<file path=ppt\handoutMasters\handoutMaster1.xml><?xml version="1.0" encoding="utf-8"?>
+<p:handoutMaster xmlns:a="http://schemas.openxmlformats.org/drawingml/2006/main" xmlns:r="http://schemas.openxmlformats.org/officeDocument/2006/relationships" xmlns:p="http://schemas.openxmlformats.org/presentationml/2006/main">
+  <p:cSld>
+    <p:bg>
+      <p:bgRef idx="1001">
+        <a:schemeClr val="bg1"/>
+      </p:bgRef>
+    </p:bg>
+    <p:spTree>
+      <p:nvGrpSpPr>
+        <p:cNvPr id="1" name=""/>
+        <p:cNvGrpSpPr/>
+        <p:nvPr/>
+      </p:nvGrpSpPr>
+      <p:grpSpPr>
+        <a:xfrm>
+          <a:off x="0" y="0"/>
+          <a:ext cx="0" cy="0"/>
+          <a:chOff x="0" y="0"/>
+          <a:chExt cx="0" cy="0"/>
+        </a:xfrm>
+      </p:grpSpPr>
+      <p:sp>
+        <p:nvSpPr>
+          <p:cNvPr id="2" name="Header Placeholder 1"/>
+          <p:cNvSpPr>
+            <a:spLocks noGrp="1"/>
+          </p:cNvSpPr>
+          <p:nvPr>
+            <p:ph type="hdr" sz="quarter"/>
+          </p:nvPr>
+        </p:nvSpPr>
+        <p:spPr>
+          <a:xfrm>
+            <a:off x="0" y="0"/>
+            <a:ext cx="2971800" cy="457200"/>
+          </a:xfrm>
+          <a:prstGeom prst="rect">
+            <a:avLst/>
+          </a:prstGeom>
+        </p:spPr>
+        <p:txBody>
+          <a:bodyPr vert="horz" lIns="91440" tIns="45720" rIns="91440" bIns="45720" rtlCol="0"/>
+          <a:lstStyle>
+            <a:lvl1pPr algn="l">
+              <a:defRPr sz="1200"/>
+            </a:lvl1pPr>
+          </a:lstStyle>
+          <a:p>
+            <a:endParaRPr lang="en-US"/>
+          </a:p>
+        </p:txBody>
+      </p:sp>
+      <p:sp>
+        <p:nvSpPr>
+          <p:cNvPr id="3" name="Date Placeholder 2"/>
+          <p:cNvSpPr>
+            <a:spLocks noGrp="1"/>
+          </p:cNvSpPr>
+          <p:nvPr>
+            <p:ph type="dt" sz="quarter" idx="1"/>
+          </p:nvPr>
+        </p:nvSpPr>
+        <p:spPr>
+          <a:xfrm>
+            <a:off x="3884613" y="0"/>
+            <a:ext cx="2971800" cy="457200"/>
+          </a:xfrm>
+          <a:prstGeom prst="rect">
+            <a:avLst/>
+          </a:prstGeom>
+        </p:spPr>
+        <p:txBody>
+          <a:bodyPr vert="horz" lIns="91440" tIns="45720" rIns="91440" bIns="45720" rtlCol="0"/>
+          <a:lstStyle>
+            <a:lvl1pPr algn="r">
+              <a:defRPr sz="1200"/>
+            </a:lvl1pPr>
+          </a:lstStyle>
+          <a:p>
+            <a:fld id="{08BD4FA9-F3CE-45B3-A980-C331C6F1EF65}" type="datetimeFigureOut">
+              <a:rPr lang="en-US" smtClean="0"/>
+              <a:t>12/16/2025</a:t>
+            </a:fld>
+            <a:endParaRPr lang="en-US"/>
+          </a:p>
+        </p:txBody>
+      </p:sp>
+      <p:sp>
+        <p:nvSpPr>
+          <p:cNvPr id="4" name="Footer Placeholder 3"/>
+          <p:cNvSpPr>
+            <a:spLocks noGrp="1"/>
+          </p:cNvSpPr>
+          <p:nvPr>
+            <p:ph type="ftr" sz="quarter" idx="2"/>
+          </p:nvPr>
+        </p:nvSpPr>
+        <p:spPr>
+          <a:xfrm>
+            <a:off x="0" y="8685213"/>
+            <a:ext cx="2971800" cy="457200"/>
+          </a:xfrm>
+          <a:prstGeom prst="rect">
+            <a:avLst/>
+          </a:prstGeom>
+        </p:spPr>
+        <p:txBody>
+          <a:bodyPr vert="horz" lIns="91440" tIns="45720" rIns="91440" bIns="45720" rtlCol="0" anchor="b"/>
+          <a:lstStyle>
+            <a:lvl1pPr algn="l">
+              <a:defRPr sz="1200"/>
+            </a:lvl1pPr>
+          </a:lstStyle>
+          <a:p>
+            <a:endParaRPr lang="en-US"/>
+          </a:p>
+        </p:txBody>
+      </p:sp>
+      <p:sp>
+        <p:nvSpPr>
+          <p:cNvPr id="5" name="Slide Number Placeholder 4"/>
+          <p:cNvSpPr>
+            <a:spLocks noGrp="1"/>
+          </p:cNvSpPr>
+          <p:nvPr>
+            <p:ph type="sldNum" sz="quarter" idx="3"/>
+          </p:nvPr>
+        </p:nvSpPr>
+        <p:spPr>
+          <a:xfrm>
+            <a:off x="3884613" y="8685213"/>
+            <a:ext cx="2971800" cy="457200"/>
+          </a:xfrm>
+          <a:prstGeom prst="rect">
+            <a:avLst/>
+          </a:prstGeom>
+        </p:spPr>
+        <p:txBody>
+          <a:bodyPr vert="horz" lIns="91440" tIns="45720" rIns="91440" bIns="45720" rtlCol="0" anchor="b"/>
+          <a:lstStyle>
+            <a:lvl1pPr algn="r">
+              <a:defRPr sz="1200"/>
+            </a:lvl1pPr>
+          </a:lstStyle>
+          <a:p>
+            <a:fld id="{C7CD5E95-8CAD-4274-BFFA-CD87442DEA8C}" type="slidenum">
+              <a:rPr lang="en-US" smtClean="0"/>
+              <a:t>‹#›</a:t>
+            </a:fld>
+            <a:endParaRPr lang="en-US"/>
+          </a:p>
+        </p:txBody>
+      </p:sp>
+    </p:spTree>
+    <p:extLst>
+      <p:ext uri="{BB962C8B-B14F-4D97-AF65-F5344CB8AC3E}">
+        <p14:creationId xmlns:p14="http://schemas.microsoft.com/office/powerpoint/2010/main" val="1310769078"/>
+      </p:ext>
+    </p:extLst>
+  </p:cSld>
+  <p:clrMap bg1="lt1" tx1="dk1" bg2="lt2" tx2="dk2" accent1="accent1" accent2="accent2" accent3="accent3" accent4="accent4" accent5="accent5" accent6="accent6" hlink="hlink" folHlink="folHlink"/>
+</p:handoutMaster>
+</file>
+
+<file path=ppt\notesMasters\notesMaster1.xml><?xml version="1.0" encoding="utf-8"?>
+<p:notesMaster xmlns:a="http://schemas.openxmlformats.org/drawingml/2006/main" xmlns:r="http://schemas.openxmlformats.org/officeDocument/2006/relationships" xmlns:p="http://schemas.openxmlformats.org/presentationml/2006/main">
+  <p:cSld>
+    <p:bg>
+      <p:bgRef idx="1001">
+        <a:schemeClr val="bg1"/>
+      </p:bgRef>
+    </p:bg>
+    <p:spTree>
+      <p:nvGrpSpPr>
+        <p:cNvPr id="1" name=""/>
+        <p:cNvGrpSpPr/>
+        <p:nvPr/>
+      </p:nvGrpSpPr>
+      <p:grpSpPr>
+        <a:xfrm>
+          <a:off x="0" y="0"/>
+          <a:ext cx="0" cy="0"/>
+          <a:chOff x="0" y="0"/>
+          <a:chExt cx="0" cy="0"/>
+        </a:xfrm>
+      </p:grpSpPr>
+      <p:sp>
+        <p:nvSpPr>
+          <p:cNvPr id="2" name="Header Placeholder 1"/>
+          <p:cNvSpPr>
+            <a:spLocks noGrp="1"/>
+          </p:cNvSpPr>
+          <p:nvPr>
+            <p:ph type="hdr" sz="quarter"/>
+          </p:nvPr>
+        </p:nvSpPr>
+        <p:spPr>
+          <a:xfrm>
+            <a:off x="0" y="0"/>
+            <a:ext cx="2971800" cy="458788"/>
+          </a:xfrm>
+          <a:prstGeom prst="rect">
+            <a:avLst/>
+          </a:prstGeom>
+        </p:spPr>
+        <p:txBody>
+          <a:bodyPr vert="horz" lIns="91440" tIns="45720" rIns="91440" bIns="45720" rtlCol="0"/>
+          <a:lstStyle>
+            <a:lvl1pPr algn="l">
+              <a:defRPr sz="1200"/>
+            </a:lvl1pPr>
+          </a:lstStyle>
+          <a:p>
+            <a:endParaRPr lang="en-US"/>
+          </a:p>
+        </p:txBody>
+      </p:sp>
+      <p:sp>
+        <p:nvSpPr>
+          <p:cNvPr id="3" name="Date Placeholder 2"/>
+          <p:cNvSpPr>
+            <a:spLocks noGrp="1"/>
+          </p:cNvSpPr>
+          <p:nvPr>
+            <p:ph type="dt" idx="1"/>
+          </p:nvPr>
+        </p:nvSpPr>
+        <p:spPr>
+          <a:xfrm>
+            <a:off x="3884613" y="0"/>
+            <a:ext cx="2971800" cy="458788"/>
+          </a:xfrm>
+          <a:prstGeom prst="rect">
+            <a:avLst/>
+          </a:prstGeom>
+        </p:spPr>
+        <p:txBody>
+          <a:bodyPr vert="horz" lIns="91440" tIns="45720" rIns="91440" bIns="45720" rtlCol="0"/>
+          <a:lstStyle>
+            <a:lvl1pPr algn="r">
+              <a:defRPr sz="1200"/>
+            </a:lvl1pPr>
+          </a:lstStyle>
+          <a:p>
+            <a:fld id="{B1271872-C532-4BFE-903F-C7072979174B}" type="datetimeFigureOut">
+              <a:rPr lang="en-US" smtClean="0"/>
+              <a:t>12/16/2025</a:t>
+            </a:fld>
+            <a:endParaRPr lang="en-US"/>
+          </a:p>
+        </p:txBody>
+      </p:sp>
+      <p:sp>
+        <p:nvSpPr>
+          <p:cNvPr id="4" name="Slide Image Placeholder 3"/>
+          <p:cNvSpPr>
+            <a:spLocks noGrp="1" noRot="1" noChangeAspect="1"/>
+          </p:cNvSpPr>
+          <p:nvPr>
+            <p:ph type="sldImg" idx="2"/>
+          </p:nvPr>
+        </p:nvSpPr>
+        <p:spPr>
+          <a:xfrm>
+            <a:off x="1371600" y="1143000"/>
+            <a:ext cx="4114800" cy="3086100"/>
+          </a:xfrm>
+          <a:prstGeom prst="rect">
+            <a:avLst/>
+          </a:prstGeom>
+          <a:noFill/>
+          <a:ln w="12700">
+            <a:solidFill>
+              <a:prstClr val="black"/>
+            </a:solidFill>
+          </a:ln>
+        </p:spPr>
+        <p:txBody>
+          <a:bodyPr vert="horz" lIns="91440" tIns="45720" rIns="91440" bIns="45720" rtlCol="0" anchor="ctr"/>
+          <a:lstStyle/>
+          <a:p>
+            <a:endParaRPr lang="en-US"/>
+          </a:p>
+        </p:txBody>
+      </p:sp>
+      <p:sp>
+        <p:nvSpPr>
+          <p:cNvPr id="5" name="Notes Placeholder 4"/>
+          <p:cNvSpPr>
+            <a:spLocks noGrp="1"/>
+          </p:cNvSpPr>
+          <p:nvPr>
+            <p:ph type="body" sz="quarter" idx="3"/>
+          </p:nvPr>
+        </p:nvSpPr>
+        <p:spPr>
+          <a:xfrm>
+            <a:off x="685800" y="4400550"/>
+            <a:ext cx="5486400" cy="3600450"/>
+          </a:xfrm>
+          <a:prstGeom prst="rect">
+            <a:avLst/>
+          </a:prstGeom>
+        </p:spPr>
+        <p:txBody>
+          <a:bodyPr vert="horz" lIns="91440" tIns="45720" rIns="91440" bIns="45720" rtlCol="0"/>
+          <a:lstStyle/>
+          <a:p>
+            <a:pPr lvl="0"/>
+            <a:r>
+              <a:rPr lang="en-US"/>
+              <a:t>Click to edit Master text styles</a:t>
+            </a:r>
+          </a:p>
+          <a:p>
+            <a:pPr lvl="1"/>
+            <a:r>
+              <a:rPr lang="en-US"/>
+              <a:t>Second level</a:t>
+            </a:r>
+          </a:p>
+          <a:p>
+            <a:pPr lvl="2"/>
+            <a:r>
+              <a:rPr lang="en-US"/>
+              <a:t>Third level</a:t>
+            </a:r>
+          </a:p>
+          <a:p>
+            <a:pPr lvl="3"/>
+            <a:r>
+              <a:rPr lang="en-US"/>
+              <a:t>Fourth level</a:t>
+            </a:r>
+          </a:p>
+          <a:p>
+            <a:pPr lvl="4"/>
+            <a:r>
+              <a:rPr lang="en-US"/>
+              <a:t>Fifth level</a:t>
+            </a:r>
+          </a:p>
+        </p:txBody>
+      </p:sp>
+      <p:sp>
+        <p:nvSpPr>
+          <p:cNvPr id="6" name="Footer Placeholder 5"/>
+          <p:cNvSpPr>
+            <a:spLocks noGrp="1"/>
+          </p:cNvSpPr>
+          <p:nvPr>
+            <p:ph type="ftr" sz="quarter" idx="4"/>
+          </p:nvPr>
+        </p:nvSpPr>
+        <p:spPr>
+          <a:xfrm>
+            <a:off x="0" y="8685213"/>
+            <a:ext cx="2971800" cy="458787"/>
+          </a:xfrm>
+          <a:prstGeom prst="rect">
+            <a:avLst/>
+          </a:prstGeom>
+        </p:spPr>
+        <p:txBody>
+          <a:bodyPr vert="horz" lIns="91440" tIns="45720" rIns="91440" bIns="45720" rtlCol="0" anchor="b"/>
+          <a:lstStyle>
+            <a:lvl1pPr algn="l">
+              <a:defRPr sz="1200"/>
+            </a:lvl1pPr>
+          </a:lstStyle>
+          <a:p>
+            <a:endParaRPr lang="en-US"/>
+          </a:p>
+        </p:txBody>
+      </p:sp>
+      <p:sp>
+        <p:nvSpPr>
+          <p:cNvPr id="7" name="Slide Number Placeholder 6"/>
+          <p:cNvSpPr>
+            <a:spLocks noGrp="1"/>
+          </p:cNvSpPr>
+          <p:nvPr>
+            <p:ph type="sldNum" sz="quarter" idx="5"/>
+          </p:nvPr>
+        </p:nvSpPr>
+        <p:spPr>
+          <a:xfrm>
+            <a:off x="3884613" y="8685213"/>
+            <a:ext cx="2971800" cy="458787"/>
+          </a:xfrm>
+          <a:prstGeom prst="rect">
+            <a:avLst/>
+          </a:prstGeom>
+        </p:spPr>
+        <p:txBody>
+          <a:bodyPr vert="horz" lIns="91440" tIns="45720" rIns="91440" bIns="45720" rtlCol="0" anchor="b"/>
+          <a:lstStyle>
+            <a:lvl1pPr algn="r">
+              <a:defRPr sz="1200"/>
+            </a:lvl1pPr>
+          </a:lstStyle>
+          <a:p>
+            <a:fld id="{E94B1ED8-6108-4710-99B1-764EAA2F18C6}" type="slidenum">
+              <a:rPr lang="en-US" smtClean="0"/>
+              <a:t>‹#›</a:t>
+            </a:fld>
+            <a:endParaRPr lang="en-US"/>
+          </a:p>
+        </p:txBody>
+      </p:sp>
+    </p:spTree>
+    <p:extLst>
+      <p:ext uri="{BB962C8B-B14F-4D97-AF65-F5344CB8AC3E}">
+        <p14:creationId xmlns:p14="http://schemas.microsoft.com/office/powerpoint/2010/main" val="2614429609"/>
+      </p:ext>
+    </p:extLst>
+  </p:cSld>
+  <p:clrMap bg1="lt1" tx1="dk1" bg2="lt2" tx2="dk2" accent1="accent1" accent2="accent2" accent3="accent3" accent4="accent4" accent5="accent5" accent6="accent6" hlink="hlink" folHlink="folHlink"/>
+  <p:notesStyle>
+    <a:lvl1pPr marL="0" algn="l" defTabSz="914400" rtl="0" eaLnBrk="1" latinLnBrk="0" hangingPunct="1">
+      <a:defRPr sz="1200" kern="1200">
+        <a:solidFill>
+          <a:schemeClr val="tx1"/>
+        </a:solidFill>
+        <a:latin typeface="+mn-lt"/>
+        <a:ea typeface="+mn-ea"/>
+        <a:cs typeface="+mn-cs"/>
+      </a:defRPr>
+    </a:lvl1pPr>
+    <a:lvl2pPr marL="457200" algn="l" defTabSz="914400" rtl="0" eaLnBrk="1" latinLnBrk="0" hangingPunct="1">
+      <a:defRPr sz="1200" kern="1200">
+        <a:solidFill>
+          <a:schemeClr val="tx1"/>
+        </a:solidFill>
+        <a:latin typeface="+mn-lt"/>
+        <a:ea typeface="+mn-ea"/>
+        <a:cs typeface="+mn-cs"/>
+      </a:defRPr>
+    </a:lvl2pPr>
+    <a:lvl3pPr marL="914400" algn="l" defTabSz="914400" rtl="0" eaLnBrk="1" latinLnBrk="0" hangingPunct="1">
+      <a:defRPr sz="1200" kern="1200">
+        <a:solidFill>
+          <a:schemeClr val="tx1"/>
+        </a:solidFill>
+        <a:latin typeface="+mn-lt"/>
+        <a:ea typeface="+mn-ea"/>
+        <a:cs typeface="+mn-cs"/>
+      </a:defRPr>
+    </a:lvl3pPr>
+    <a:lvl4pPr marL="1371600" algn="l" defTabSz="914400" rtl="0" eaLnBrk="1" latinLnBrk="0" hangingPunct="1">
+      <a:defRPr sz="1200" kern="1200">
+        <a:solidFill>
+          <a:schemeClr val="tx1"/>
+        </a:solidFill>
+        <a:latin typeface="+mn-lt"/>
+        <a:ea typeface="+mn-ea"/>
+        <a:cs typeface="+mn-cs"/>
+      </a:defRPr>
+    </a:lvl4pPr>
+    <a:lvl5pPr marL="1828800" algn="l" defTabSz="914400" rtl="0" eaLnBrk="1" latinLnBrk="0" hangingPunct="1">
+      <a:defRPr sz="1200" kern="1200">
+        <a:solidFill>
+          <a:schemeClr val="tx1"/>
+        </a:solidFill>
+        <a:latin typeface="+mn-lt"/>
+        <a:ea typeface="+mn-ea"/>
+        <a:cs typeface="+mn-cs"/>
+      </a:defRPr>
+    </a:lvl5pPr>
+    <a:lvl6pPr marL="2286000" algn="l" defTabSz="914400" rtl="0" eaLnBrk="1" latinLnBrk="0" hangingPunct="1">
+      <a:defRPr sz="1200" kern="1200">
+        <a:solidFill>
+          <a:schemeClr val="tx1"/>
+        </a:solidFill>
+        <a:latin typeface="+mn-lt"/>
+        <a:ea typeface="+mn-ea"/>
+        <a:cs typeface="+mn-cs"/>
+      </a:defRPr>
+    </a:lvl6pPr>
+    <a:lvl7pPr marL="2743200" algn="l" defTabSz="914400" rtl="0" eaLnBrk="1" latinLnBrk="0" hangingPunct="1">
+      <a:defRPr sz="1200" kern="1200">
+        <a:solidFill>
+          <a:schemeClr val="tx1"/>
+        </a:solidFill>
+        <a:latin typeface="+mn-lt"/>
+        <a:ea typeface="+mn-ea"/>
+        <a:cs typeface="+mn-cs"/>
+      </a:defRPr>
+    </a:lvl7pPr>
+    <a:lvl8pPr marL="3200400" algn="l" defTabSz="914400" rtl="0" eaLnBrk="1" latinLnBrk="0" hangingPunct="1">
+      <a:defRPr sz="1200" kern="1200">
+        <a:solidFill>
+          <a:schemeClr val="tx1"/>
+        </a:solidFill>
+        <a:latin typeface="+mn-lt"/>
+        <a:ea typeface="+mn-ea"/>
+        <a:cs typeface="+mn-cs"/>
+      </a:defRPr>
+    </a:lvl8pPr>
+    <a:lvl9pPr marL="3657600" algn="l" defTabSz="914400" rtl="0" eaLnBrk="1" latinLnBrk="0" hangingPunct="1">
+      <a:defRPr sz="1200" kern="1200">
+        <a:solidFill>
+          <a:schemeClr val="tx1"/>
+        </a:solidFill>
+        <a:latin typeface="+mn-lt"/>
+        <a:ea typeface="+mn-ea"/>
+        <a:cs typeface="+mn-cs"/>
+      </a:defRPr>
+    </a:lvl9pPr>
+  </p:notesStyle>
+</p:notesMaster>
+</file>
+
+<file path=ppt\notesSlides\notesSlide1.xml><?xml version="1.0" encoding="utf-8"?>
+<p:notes xmlns:a="http://schemas.openxmlformats.org/drawingml/2006/main" xmlns:r="http://schemas.openxmlformats.org/officeDocument/2006/relationships" xmlns:p="http://schemas.openxmlformats.org/presentationml/2006/main">
+  <p:cSld>
+    <p:spTree>
+      <p:nvGrpSpPr>
+        <p:cNvPr id="1" name=""/>
+        <p:cNvGrpSpPr/>
+        <p:nvPr/>
+      </p:nvGrpSpPr>
+      <p:grpSpPr>
+        <a:xfrm>
+          <a:off x="0" y="0"/>
+          <a:ext cx="0" cy="0"/>
+          <a:chOff x="0" y="0"/>
+          <a:chExt cx="0" cy="0"/>
+        </a:xfrm>
+      </p:grpSpPr>
+      <p:sp>
+        <p:nvSpPr>
+          <p:cNvPr id="2" name="Slide Image Placeholder 1"/>
+          <p:cNvSpPr>
+            <a:spLocks noGrp="1" noRot="1" noChangeAspect="1"/>
+          </p:cNvSpPr>
+          <p:nvPr>
+            <p:ph type="sldImg"/>
+          </p:nvPr>
+        </p:nvSpPr>
+        <p:spPr/>
+      </p:sp>
+      <p:sp>
+        <p:nvSpPr>
+          <p:cNvPr id="3" name="Notes Placeholder 2"/>
+          <p:cNvSpPr>
+            <a:spLocks noGrp="1"/>
+          </p:cNvSpPr>
+          <p:nvPr>
+            <p:ph type="body" idx="1"/>
+          </p:nvPr>
+        </p:nvSpPr>
+        <p:spPr/>
+        <p:txBody>
+          <a:bodyPr/>
+          <a:lstStyle/>
+          <a:p>
+            <a:r>
+              <a:rPr lang="en-CA" dirty="0"/>
+              <a:t>In 1935, Maurice Bartlett presented the first paper on the topic of interactions in three-way tables. </a:t>
+            </a:r>
+          </a:p>
+          <a:p>
+            <a:r>
+              <a:rPr lang="en-CA" dirty="0"/>
+              <a:t>His main example concerned an agricultural experiment on plum root cuttings …</a:t>
+            </a:r>
+          </a:p>
+        </p:txBody>
+      </p:sp>
+      <p:sp>
+        <p:nvSpPr>
+          <p:cNvPr id="4" name="Slide Number Placeholder 3"/>
+          <p:cNvSpPr>
+            <a:spLocks noGrp="1"/>
+          </p:cNvSpPr>
+          <p:nvPr>
+            <p:ph type="sldNum" sz="quarter" idx="5"/>
+          </p:nvPr>
+        </p:nvSpPr>
+        <p:spPr/>
+        <p:txBody>
+          <a:bodyPr/>
+          <a:lstStyle/>
+          <a:p>
+            <a:fld id="{E94B1ED8-6108-4710-99B1-764EAA2F18C6}" type="slidenum">
+              <a:rPr lang="en-US" smtClean="0"/>
+              <a:t>12</a:t>
+            </a:fld>
+            <a:endParaRPr lang="en-US"/>
+          </a:p>
+        </p:txBody>
+      </p:sp>
+    </p:spTree>
+    <p:extLst>
+      <p:ext uri="{BB962C8B-B14F-4D97-AF65-F5344CB8AC3E}">
+        <p14:creationId xmlns:p14="http://schemas.microsoft.com/office/powerpoint/2010/main" val="498954036"/>
+      </p:ext>
+    </p:extLst>
+  </p:cSld>
+  <p:clrMapOvr>
+    <a:masterClrMapping/>
+  </p:clrMapOvr>
+</p:notes>
+</file>
+
+<file path=ppt\notesSlides\notesSlide2.xml><?xml version="1.0" encoding="utf-8"?>
+<p:notes xmlns:a="http://schemas.openxmlformats.org/drawingml/2006/main" xmlns:r="http://schemas.openxmlformats.org/officeDocument/2006/relationships" xmlns:p="http://schemas.openxmlformats.org/presentationml/2006/main">
+  <p:cSld>
+    <p:spTree>
+      <p:nvGrpSpPr>
+        <p:cNvPr id="1" name=""/>
+        <p:cNvGrpSpPr/>
+        <p:nvPr/>
+      </p:nvGrpSpPr>
+      <p:grpSpPr>
+        <a:xfrm>
+          <a:off x="0" y="0"/>
+          <a:ext cx="0" cy="0"/>
+          <a:chOff x="0" y="0"/>
+          <a:chExt cx="0" cy="0"/>
+        </a:xfrm>
+      </p:grpSpPr>
+      <p:sp>
+        <p:nvSpPr>
+          <p:cNvPr id="2" name="Slide Image Placeholder 1"/>
+          <p:cNvSpPr>
+            <a:spLocks noGrp="1" noRot="1" noChangeAspect="1"/>
+          </p:cNvSpPr>
+          <p:nvPr>
+            <p:ph type="sldImg"/>
+          </p:nvPr>
+        </p:nvSpPr>
+        <p:spPr/>
+      </p:sp>
+      <p:sp>
+        <p:nvSpPr>
+          <p:cNvPr id="3" name="Notes Placeholder 2"/>
+          <p:cNvSpPr>
+            <a:spLocks noGrp="1"/>
+          </p:cNvSpPr>
+          <p:nvPr>
+            <p:ph type="body" idx="1"/>
+          </p:nvPr>
+        </p:nvSpPr>
+        <p:spPr/>
+        <p:txBody>
+          <a:bodyPr/>
+          <a:lstStyle/>
+          <a:p>
+            <a:r>
+              <a:rPr lang="en-CA" dirty="0"/>
+              <a:t>A: for the UCB data, hair-eye color and mental impairment, no margins are fixed -&gt; Poisson</a:t>
+            </a:r>
+          </a:p>
+          <a:p>
+            <a:r>
+              <a:rPr lang="en-CA" dirty="0"/>
+              <a:t>But say we screened 600 males and 600 females, 100 in each department applying to UC Berkeley?</a:t>
+            </a:r>
+          </a:p>
+          <a:p>
+            <a:endParaRPr lang="en-CA" dirty="0"/>
+          </a:p>
+        </p:txBody>
+      </p:sp>
+      <p:sp>
+        <p:nvSpPr>
+          <p:cNvPr id="4" name="Slide Number Placeholder 3"/>
+          <p:cNvSpPr>
+            <a:spLocks noGrp="1"/>
+          </p:cNvSpPr>
+          <p:nvPr>
+            <p:ph type="sldNum" sz="quarter" idx="5"/>
+          </p:nvPr>
+        </p:nvSpPr>
+        <p:spPr/>
+        <p:txBody>
+          <a:bodyPr/>
+          <a:lstStyle/>
+          <a:p>
+            <a:fld id="{E94B1ED8-6108-4710-99B1-764EAA2F18C6}" type="slidenum">
+              <a:rPr lang="en-US" smtClean="0"/>
+              <a:t>22</a:t>
+            </a:fld>
+            <a:endParaRPr lang="en-US"/>
+          </a:p>
+        </p:txBody>
+      </p:sp>
+    </p:spTree>
+    <p:extLst>
+      <p:ext uri="{BB962C8B-B14F-4D97-AF65-F5344CB8AC3E}">
+        <p14:creationId xmlns:p14="http://schemas.microsoft.com/office/powerpoint/2010/main" val="2534160110"/>
+      </p:ext>
+    </p:extLst>
+  </p:cSld>
+  <p:clrMapOvr>
+    <a:masterClrMapping/>
+  </p:clrMapOvr>
+</p:notes>
+</file>
+
+<file path=ppt\notesSlides\notesSlide3.xml><?xml version="1.0" encoding="utf-8"?>
+<p:notes xmlns:a="http://schemas.openxmlformats.org/drawingml/2006/main" xmlns:r="http://schemas.openxmlformats.org/officeDocument/2006/relationships" xmlns:p="http://schemas.openxmlformats.org/presentationml/2006/main">
+  <p:cSld>
+    <p:spTree>
+      <p:nvGrpSpPr>
+        <p:cNvPr id="1" name=""/>
+        <p:cNvGrpSpPr/>
+        <p:nvPr/>
+      </p:nvGrpSpPr>
+      <p:grpSpPr>
+        <a:xfrm>
+          <a:off x="0" y="0"/>
+          <a:ext cx="0" cy="0"/>
+          <a:chOff x="0" y="0"/>
+          <a:chExt cx="0" cy="0"/>
+        </a:xfrm>
+      </p:grpSpPr>
+      <p:sp>
+        <p:nvSpPr>
+          <p:cNvPr id="2" name="Slide Image Placeholder 1"/>
+          <p:cNvSpPr>
+            <a:spLocks noGrp="1" noRot="1" noChangeAspect="1"/>
+          </p:cNvSpPr>
+          <p:nvPr>
+            <p:ph type="sldImg"/>
+          </p:nvPr>
+        </p:nvSpPr>
+        <p:spPr/>
+      </p:sp>
+      <p:sp>
+        <p:nvSpPr>
+          <p:cNvPr id="3" name="Notes Placeholder 2"/>
+          <p:cNvSpPr>
+            <a:spLocks noGrp="1"/>
+          </p:cNvSpPr>
+          <p:nvPr>
+            <p:ph type="body" idx="1"/>
+          </p:nvPr>
+        </p:nvSpPr>
+        <p:spPr/>
+        <p:txBody>
+          <a:bodyPr/>
+          <a:lstStyle/>
+          <a:p>
+            <a:endParaRPr lang="en-CA"/>
+          </a:p>
+        </p:txBody>
+      </p:sp>
+      <p:sp>
+        <p:nvSpPr>
+          <p:cNvPr id="4" name="Slide Number Placeholder 3"/>
+          <p:cNvSpPr>
+            <a:spLocks noGrp="1"/>
+          </p:cNvSpPr>
+          <p:nvPr>
+            <p:ph type="sldNum" sz="quarter" idx="5"/>
+          </p:nvPr>
+        </p:nvSpPr>
+        <p:spPr/>
+        <p:txBody>
+          <a:bodyPr/>
+          <a:lstStyle/>
+          <a:p>
+            <a:fld id="{33E20828-1A1A-4225-BE3A-F8540A5E6146}" type="slidenum">
+              <a:rPr lang="en-US" smtClean="0"/>
+              <a:t>43</a:t>
+            </a:fld>
+            <a:endParaRPr lang="en-US"/>
+          </a:p>
+        </p:txBody>
+      </p:sp>
+    </p:spTree>
+    <p:extLst>
+      <p:ext uri="{BB962C8B-B14F-4D97-AF65-F5344CB8AC3E}">
+        <p14:creationId xmlns:p14="http://schemas.microsoft.com/office/powerpoint/2010/main" val="1127527337"/>
+      </p:ext>
+    </p:extLst>
+  </p:cSld>
+  <p:clrMapOvr>
+    <a:masterClrMapping/>
+  </p:clrMapOvr>
+</p:notes>
+</file>
+
+<file path=ppt\presProps.xml><?xml version="1.0" encoding="utf-8"?>
+<p:presentationPr xmlns:a="http://schemas.openxmlformats.org/drawingml/2006/main" xmlns:r="http://schemas.openxmlformats.org/officeDocument/2006/relationships" xmlns:p="http://schemas.openxmlformats.org/presentationml/2006/main">
+  <p:extLst>
+    <p:ext uri="{E76CE94A-603C-4142-B9EB-6D1370010A27}">
+      <p14:discardImageEditData xmlns:p14="http://schemas.microsoft.com/office/powerpoint/2010/main" val="0"/>
+    </p:ext>
+    <p:ext uri="{D31A062A-798A-4329-ABDD-BBA856620510}">
+      <p14:defaultImageDpi xmlns:p14="http://schemas.microsoft.com/office/powerpoint/2010/main" val="220"/>
+    </p:ext>
+    <p:ext uri="{FD5EFAAD-0ECE-453E-9831-46B23BE46B34}">
+      <p15:chartTrackingRefBased xmlns:p15="http://schemas.microsoft.com/office/powerpoint/2012/main" val="0"/>
+    </p:ext>
+  </p:extLst>
+</p:presentationPr>
+</file>
+
+<file path=ppt\presentation.xml><?xml version="1.0" encoding="utf-8"?>
 <p:presentation xmlns:a="http://schemas.openxmlformats.org/drawingml/2006/main" xmlns:r="http://schemas.openxmlformats.org/officeDocument/2006/relationships" xmlns:p="http://schemas.openxmlformats.org/presentationml/2006/main" embedTrueTypeFonts="1" saveSubsetFonts="1">
   <p:sldMasterIdLst>
     <p:sldMasterId id="2147483660" r:id="rId1"/>
@@ -344,794 +1297,7 @@
 </p:presentation>
 </file>
 
-<file path=ppt/handoutMasters/handoutMaster1.xml><?xml version="1.0" encoding="utf-8"?>
-<p:handoutMaster xmlns:a="http://schemas.openxmlformats.org/drawingml/2006/main" xmlns:r="http://schemas.openxmlformats.org/officeDocument/2006/relationships" xmlns:p="http://schemas.openxmlformats.org/presentationml/2006/main">
-  <p:cSld>
-    <p:bg>
-      <p:bgRef idx="1001">
-        <a:schemeClr val="bg1"/>
-      </p:bgRef>
-    </p:bg>
-    <p:spTree>
-      <p:nvGrpSpPr>
-        <p:cNvPr id="1" name=""/>
-        <p:cNvGrpSpPr/>
-        <p:nvPr/>
-      </p:nvGrpSpPr>
-      <p:grpSpPr>
-        <a:xfrm>
-          <a:off x="0" y="0"/>
-          <a:ext cx="0" cy="0"/>
-          <a:chOff x="0" y="0"/>
-          <a:chExt cx="0" cy="0"/>
-        </a:xfrm>
-      </p:grpSpPr>
-      <p:sp>
-        <p:nvSpPr>
-          <p:cNvPr id="2" name="Header Placeholder 1"/>
-          <p:cNvSpPr>
-            <a:spLocks noGrp="1"/>
-          </p:cNvSpPr>
-          <p:nvPr>
-            <p:ph type="hdr" sz="quarter"/>
-          </p:nvPr>
-        </p:nvSpPr>
-        <p:spPr>
-          <a:xfrm>
-            <a:off x="0" y="0"/>
-            <a:ext cx="2971800" cy="457200"/>
-          </a:xfrm>
-          <a:prstGeom prst="rect">
-            <a:avLst/>
-          </a:prstGeom>
-        </p:spPr>
-        <p:txBody>
-          <a:bodyPr vert="horz" lIns="91440" tIns="45720" rIns="91440" bIns="45720" rtlCol="0"/>
-          <a:lstStyle>
-            <a:lvl1pPr algn="l">
-              <a:defRPr sz="1200"/>
-            </a:lvl1pPr>
-          </a:lstStyle>
-          <a:p>
-            <a:endParaRPr lang="en-US"/>
-          </a:p>
-        </p:txBody>
-      </p:sp>
-      <p:sp>
-        <p:nvSpPr>
-          <p:cNvPr id="3" name="Date Placeholder 2"/>
-          <p:cNvSpPr>
-            <a:spLocks noGrp="1"/>
-          </p:cNvSpPr>
-          <p:nvPr>
-            <p:ph type="dt" sz="quarter" idx="1"/>
-          </p:nvPr>
-        </p:nvSpPr>
-        <p:spPr>
-          <a:xfrm>
-            <a:off x="3884613" y="0"/>
-            <a:ext cx="2971800" cy="457200"/>
-          </a:xfrm>
-          <a:prstGeom prst="rect">
-            <a:avLst/>
-          </a:prstGeom>
-        </p:spPr>
-        <p:txBody>
-          <a:bodyPr vert="horz" lIns="91440" tIns="45720" rIns="91440" bIns="45720" rtlCol="0"/>
-          <a:lstStyle>
-            <a:lvl1pPr algn="r">
-              <a:defRPr sz="1200"/>
-            </a:lvl1pPr>
-          </a:lstStyle>
-          <a:p>
-            <a:fld id="{08BD4FA9-F3CE-45B3-A980-C331C6F1EF65}" type="datetimeFigureOut">
-              <a:rPr lang="en-US" smtClean="0"/>
-              <a:t>12/16/2025</a:t>
-            </a:fld>
-            <a:endParaRPr lang="en-US"/>
-          </a:p>
-        </p:txBody>
-      </p:sp>
-      <p:sp>
-        <p:nvSpPr>
-          <p:cNvPr id="4" name="Footer Placeholder 3"/>
-          <p:cNvSpPr>
-            <a:spLocks noGrp="1"/>
-          </p:cNvSpPr>
-          <p:nvPr>
-            <p:ph type="ftr" sz="quarter" idx="2"/>
-          </p:nvPr>
-        </p:nvSpPr>
-        <p:spPr>
-          <a:xfrm>
-            <a:off x="0" y="8685213"/>
-            <a:ext cx="2971800" cy="457200"/>
-          </a:xfrm>
-          <a:prstGeom prst="rect">
-            <a:avLst/>
-          </a:prstGeom>
-        </p:spPr>
-        <p:txBody>
-          <a:bodyPr vert="horz" lIns="91440" tIns="45720" rIns="91440" bIns="45720" rtlCol="0" anchor="b"/>
-          <a:lstStyle>
-            <a:lvl1pPr algn="l">
-              <a:defRPr sz="1200"/>
-            </a:lvl1pPr>
-          </a:lstStyle>
-          <a:p>
-            <a:endParaRPr lang="en-US"/>
-          </a:p>
-        </p:txBody>
-      </p:sp>
-      <p:sp>
-        <p:nvSpPr>
-          <p:cNvPr id="5" name="Slide Number Placeholder 4"/>
-          <p:cNvSpPr>
-            <a:spLocks noGrp="1"/>
-          </p:cNvSpPr>
-          <p:nvPr>
-            <p:ph type="sldNum" sz="quarter" idx="3"/>
-          </p:nvPr>
-        </p:nvSpPr>
-        <p:spPr>
-          <a:xfrm>
-            <a:off x="3884613" y="8685213"/>
-            <a:ext cx="2971800" cy="457200"/>
-          </a:xfrm>
-          <a:prstGeom prst="rect">
-            <a:avLst/>
-          </a:prstGeom>
-        </p:spPr>
-        <p:txBody>
-          <a:bodyPr vert="horz" lIns="91440" tIns="45720" rIns="91440" bIns="45720" rtlCol="0" anchor="b"/>
-          <a:lstStyle>
-            <a:lvl1pPr algn="r">
-              <a:defRPr sz="1200"/>
-            </a:lvl1pPr>
-          </a:lstStyle>
-          <a:p>
-            <a:fld id="{C7CD5E95-8CAD-4274-BFFA-CD87442DEA8C}" type="slidenum">
-              <a:rPr lang="en-US" smtClean="0"/>
-              <a:t>‹#›</a:t>
-            </a:fld>
-            <a:endParaRPr lang="en-US"/>
-          </a:p>
-        </p:txBody>
-      </p:sp>
-    </p:spTree>
-    <p:extLst>
-      <p:ext uri="{BB962C8B-B14F-4D97-AF65-F5344CB8AC3E}">
-        <p14:creationId xmlns:p14="http://schemas.microsoft.com/office/powerpoint/2010/main" val="1310769078"/>
-      </p:ext>
-    </p:extLst>
-  </p:cSld>
-  <p:clrMap bg1="lt1" tx1="dk1" bg2="lt2" tx2="dk2" accent1="accent1" accent2="accent2" accent3="accent3" accent4="accent4" accent5="accent5" accent6="accent6" hlink="hlink" folHlink="folHlink"/>
-</p:handoutMaster>
-</file>
-
-<file path=ppt/notesMasters/notesMaster1.xml><?xml version="1.0" encoding="utf-8"?>
-<p:notesMaster xmlns:a="http://schemas.openxmlformats.org/drawingml/2006/main" xmlns:r="http://schemas.openxmlformats.org/officeDocument/2006/relationships" xmlns:p="http://schemas.openxmlformats.org/presentationml/2006/main">
-  <p:cSld>
-    <p:bg>
-      <p:bgRef idx="1001">
-        <a:schemeClr val="bg1"/>
-      </p:bgRef>
-    </p:bg>
-    <p:spTree>
-      <p:nvGrpSpPr>
-        <p:cNvPr id="1" name=""/>
-        <p:cNvGrpSpPr/>
-        <p:nvPr/>
-      </p:nvGrpSpPr>
-      <p:grpSpPr>
-        <a:xfrm>
-          <a:off x="0" y="0"/>
-          <a:ext cx="0" cy="0"/>
-          <a:chOff x="0" y="0"/>
-          <a:chExt cx="0" cy="0"/>
-        </a:xfrm>
-      </p:grpSpPr>
-      <p:sp>
-        <p:nvSpPr>
-          <p:cNvPr id="2" name="Header Placeholder 1"/>
-          <p:cNvSpPr>
-            <a:spLocks noGrp="1"/>
-          </p:cNvSpPr>
-          <p:nvPr>
-            <p:ph type="hdr" sz="quarter"/>
-          </p:nvPr>
-        </p:nvSpPr>
-        <p:spPr>
-          <a:xfrm>
-            <a:off x="0" y="0"/>
-            <a:ext cx="2971800" cy="458788"/>
-          </a:xfrm>
-          <a:prstGeom prst="rect">
-            <a:avLst/>
-          </a:prstGeom>
-        </p:spPr>
-        <p:txBody>
-          <a:bodyPr vert="horz" lIns="91440" tIns="45720" rIns="91440" bIns="45720" rtlCol="0"/>
-          <a:lstStyle>
-            <a:lvl1pPr algn="l">
-              <a:defRPr sz="1200"/>
-            </a:lvl1pPr>
-          </a:lstStyle>
-          <a:p>
-            <a:endParaRPr lang="en-US"/>
-          </a:p>
-        </p:txBody>
-      </p:sp>
-      <p:sp>
-        <p:nvSpPr>
-          <p:cNvPr id="3" name="Date Placeholder 2"/>
-          <p:cNvSpPr>
-            <a:spLocks noGrp="1"/>
-          </p:cNvSpPr>
-          <p:nvPr>
-            <p:ph type="dt" idx="1"/>
-          </p:nvPr>
-        </p:nvSpPr>
-        <p:spPr>
-          <a:xfrm>
-            <a:off x="3884613" y="0"/>
-            <a:ext cx="2971800" cy="458788"/>
-          </a:xfrm>
-          <a:prstGeom prst="rect">
-            <a:avLst/>
-          </a:prstGeom>
-        </p:spPr>
-        <p:txBody>
-          <a:bodyPr vert="horz" lIns="91440" tIns="45720" rIns="91440" bIns="45720" rtlCol="0"/>
-          <a:lstStyle>
-            <a:lvl1pPr algn="r">
-              <a:defRPr sz="1200"/>
-            </a:lvl1pPr>
-          </a:lstStyle>
-          <a:p>
-            <a:fld id="{B1271872-C532-4BFE-903F-C7072979174B}" type="datetimeFigureOut">
-              <a:rPr lang="en-US" smtClean="0"/>
-              <a:t>12/16/2025</a:t>
-            </a:fld>
-            <a:endParaRPr lang="en-US"/>
-          </a:p>
-        </p:txBody>
-      </p:sp>
-      <p:sp>
-        <p:nvSpPr>
-          <p:cNvPr id="4" name="Slide Image Placeholder 3"/>
-          <p:cNvSpPr>
-            <a:spLocks noGrp="1" noRot="1" noChangeAspect="1"/>
-          </p:cNvSpPr>
-          <p:nvPr>
-            <p:ph type="sldImg" idx="2"/>
-          </p:nvPr>
-        </p:nvSpPr>
-        <p:spPr>
-          <a:xfrm>
-            <a:off x="1371600" y="1143000"/>
-            <a:ext cx="4114800" cy="3086100"/>
-          </a:xfrm>
-          <a:prstGeom prst="rect">
-            <a:avLst/>
-          </a:prstGeom>
-          <a:noFill/>
-          <a:ln w="12700">
-            <a:solidFill>
-              <a:prstClr val="black"/>
-            </a:solidFill>
-          </a:ln>
-        </p:spPr>
-        <p:txBody>
-          <a:bodyPr vert="horz" lIns="91440" tIns="45720" rIns="91440" bIns="45720" rtlCol="0" anchor="ctr"/>
-          <a:lstStyle/>
-          <a:p>
-            <a:endParaRPr lang="en-US"/>
-          </a:p>
-        </p:txBody>
-      </p:sp>
-      <p:sp>
-        <p:nvSpPr>
-          <p:cNvPr id="5" name="Notes Placeholder 4"/>
-          <p:cNvSpPr>
-            <a:spLocks noGrp="1"/>
-          </p:cNvSpPr>
-          <p:nvPr>
-            <p:ph type="body" sz="quarter" idx="3"/>
-          </p:nvPr>
-        </p:nvSpPr>
-        <p:spPr>
-          <a:xfrm>
-            <a:off x="685800" y="4400550"/>
-            <a:ext cx="5486400" cy="3600450"/>
-          </a:xfrm>
-          <a:prstGeom prst="rect">
-            <a:avLst/>
-          </a:prstGeom>
-        </p:spPr>
-        <p:txBody>
-          <a:bodyPr vert="horz" lIns="91440" tIns="45720" rIns="91440" bIns="45720" rtlCol="0"/>
-          <a:lstStyle/>
-          <a:p>
-            <a:pPr lvl="0"/>
-            <a:r>
-              <a:rPr lang="en-US"/>
-              <a:t>Click to edit Master text styles</a:t>
-            </a:r>
-          </a:p>
-          <a:p>
-            <a:pPr lvl="1"/>
-            <a:r>
-              <a:rPr lang="en-US"/>
-              <a:t>Second level</a:t>
-            </a:r>
-          </a:p>
-          <a:p>
-            <a:pPr lvl="2"/>
-            <a:r>
-              <a:rPr lang="en-US"/>
-              <a:t>Third level</a:t>
-            </a:r>
-          </a:p>
-          <a:p>
-            <a:pPr lvl="3"/>
-            <a:r>
-              <a:rPr lang="en-US"/>
-              <a:t>Fourth level</a:t>
-            </a:r>
-          </a:p>
-          <a:p>
-            <a:pPr lvl="4"/>
-            <a:r>
-              <a:rPr lang="en-US"/>
-              <a:t>Fifth level</a:t>
-            </a:r>
-          </a:p>
-        </p:txBody>
-      </p:sp>
-      <p:sp>
-        <p:nvSpPr>
-          <p:cNvPr id="6" name="Footer Placeholder 5"/>
-          <p:cNvSpPr>
-            <a:spLocks noGrp="1"/>
-          </p:cNvSpPr>
-          <p:nvPr>
-            <p:ph type="ftr" sz="quarter" idx="4"/>
-          </p:nvPr>
-        </p:nvSpPr>
-        <p:spPr>
-          <a:xfrm>
-            <a:off x="0" y="8685213"/>
-            <a:ext cx="2971800" cy="458787"/>
-          </a:xfrm>
-          <a:prstGeom prst="rect">
-            <a:avLst/>
-          </a:prstGeom>
-        </p:spPr>
-        <p:txBody>
-          <a:bodyPr vert="horz" lIns="91440" tIns="45720" rIns="91440" bIns="45720" rtlCol="0" anchor="b"/>
-          <a:lstStyle>
-            <a:lvl1pPr algn="l">
-              <a:defRPr sz="1200"/>
-            </a:lvl1pPr>
-          </a:lstStyle>
-          <a:p>
-            <a:endParaRPr lang="en-US"/>
-          </a:p>
-        </p:txBody>
-      </p:sp>
-      <p:sp>
-        <p:nvSpPr>
-          <p:cNvPr id="7" name="Slide Number Placeholder 6"/>
-          <p:cNvSpPr>
-            <a:spLocks noGrp="1"/>
-          </p:cNvSpPr>
-          <p:nvPr>
-            <p:ph type="sldNum" sz="quarter" idx="5"/>
-          </p:nvPr>
-        </p:nvSpPr>
-        <p:spPr>
-          <a:xfrm>
-            <a:off x="3884613" y="8685213"/>
-            <a:ext cx="2971800" cy="458787"/>
-          </a:xfrm>
-          <a:prstGeom prst="rect">
-            <a:avLst/>
-          </a:prstGeom>
-        </p:spPr>
-        <p:txBody>
-          <a:bodyPr vert="horz" lIns="91440" tIns="45720" rIns="91440" bIns="45720" rtlCol="0" anchor="b"/>
-          <a:lstStyle>
-            <a:lvl1pPr algn="r">
-              <a:defRPr sz="1200"/>
-            </a:lvl1pPr>
-          </a:lstStyle>
-          <a:p>
-            <a:fld id="{E94B1ED8-6108-4710-99B1-764EAA2F18C6}" type="slidenum">
-              <a:rPr lang="en-US" smtClean="0"/>
-              <a:t>‹#›</a:t>
-            </a:fld>
-            <a:endParaRPr lang="en-US"/>
-          </a:p>
-        </p:txBody>
-      </p:sp>
-    </p:spTree>
-    <p:extLst>
-      <p:ext uri="{BB962C8B-B14F-4D97-AF65-F5344CB8AC3E}">
-        <p14:creationId xmlns:p14="http://schemas.microsoft.com/office/powerpoint/2010/main" val="2614429609"/>
-      </p:ext>
-    </p:extLst>
-  </p:cSld>
-  <p:clrMap bg1="lt1" tx1="dk1" bg2="lt2" tx2="dk2" accent1="accent1" accent2="accent2" accent3="accent3" accent4="accent4" accent5="accent5" accent6="accent6" hlink="hlink" folHlink="folHlink"/>
-  <p:notesStyle>
-    <a:lvl1pPr marL="0" algn="l" defTabSz="914400" rtl="0" eaLnBrk="1" latinLnBrk="0" hangingPunct="1">
-      <a:defRPr sz="1200" kern="1200">
-        <a:solidFill>
-          <a:schemeClr val="tx1"/>
-        </a:solidFill>
-        <a:latin typeface="+mn-lt"/>
-        <a:ea typeface="+mn-ea"/>
-        <a:cs typeface="+mn-cs"/>
-      </a:defRPr>
-    </a:lvl1pPr>
-    <a:lvl2pPr marL="457200" algn="l" defTabSz="914400" rtl="0" eaLnBrk="1" latinLnBrk="0" hangingPunct="1">
-      <a:defRPr sz="1200" kern="1200">
-        <a:solidFill>
-          <a:schemeClr val="tx1"/>
-        </a:solidFill>
-        <a:latin typeface="+mn-lt"/>
-        <a:ea typeface="+mn-ea"/>
-        <a:cs typeface="+mn-cs"/>
-      </a:defRPr>
-    </a:lvl2pPr>
-    <a:lvl3pPr marL="914400" algn="l" defTabSz="914400" rtl="0" eaLnBrk="1" latinLnBrk="0" hangingPunct="1">
-      <a:defRPr sz="1200" kern="1200">
-        <a:solidFill>
-          <a:schemeClr val="tx1"/>
-        </a:solidFill>
-        <a:latin typeface="+mn-lt"/>
-        <a:ea typeface="+mn-ea"/>
-        <a:cs typeface="+mn-cs"/>
-      </a:defRPr>
-    </a:lvl3pPr>
-    <a:lvl4pPr marL="1371600" algn="l" defTabSz="914400" rtl="0" eaLnBrk="1" latinLnBrk="0" hangingPunct="1">
-      <a:defRPr sz="1200" kern="1200">
-        <a:solidFill>
-          <a:schemeClr val="tx1"/>
-        </a:solidFill>
-        <a:latin typeface="+mn-lt"/>
-        <a:ea typeface="+mn-ea"/>
-        <a:cs typeface="+mn-cs"/>
-      </a:defRPr>
-    </a:lvl4pPr>
-    <a:lvl5pPr marL="1828800" algn="l" defTabSz="914400" rtl="0" eaLnBrk="1" latinLnBrk="0" hangingPunct="1">
-      <a:defRPr sz="1200" kern="1200">
-        <a:solidFill>
-          <a:schemeClr val="tx1"/>
-        </a:solidFill>
-        <a:latin typeface="+mn-lt"/>
-        <a:ea typeface="+mn-ea"/>
-        <a:cs typeface="+mn-cs"/>
-      </a:defRPr>
-    </a:lvl5pPr>
-    <a:lvl6pPr marL="2286000" algn="l" defTabSz="914400" rtl="0" eaLnBrk="1" latinLnBrk="0" hangingPunct="1">
-      <a:defRPr sz="1200" kern="1200">
-        <a:solidFill>
-          <a:schemeClr val="tx1"/>
-        </a:solidFill>
-        <a:latin typeface="+mn-lt"/>
-        <a:ea typeface="+mn-ea"/>
-        <a:cs typeface="+mn-cs"/>
-      </a:defRPr>
-    </a:lvl6pPr>
-    <a:lvl7pPr marL="2743200" algn="l" defTabSz="914400" rtl="0" eaLnBrk="1" latinLnBrk="0" hangingPunct="1">
-      <a:defRPr sz="1200" kern="1200">
-        <a:solidFill>
-          <a:schemeClr val="tx1"/>
-        </a:solidFill>
-        <a:latin typeface="+mn-lt"/>
-        <a:ea typeface="+mn-ea"/>
-        <a:cs typeface="+mn-cs"/>
-      </a:defRPr>
-    </a:lvl7pPr>
-    <a:lvl8pPr marL="3200400" algn="l" defTabSz="914400" rtl="0" eaLnBrk="1" latinLnBrk="0" hangingPunct="1">
-      <a:defRPr sz="1200" kern="1200">
-        <a:solidFill>
-          <a:schemeClr val="tx1"/>
-        </a:solidFill>
-        <a:latin typeface="+mn-lt"/>
-        <a:ea typeface="+mn-ea"/>
-        <a:cs typeface="+mn-cs"/>
-      </a:defRPr>
-    </a:lvl8pPr>
-    <a:lvl9pPr marL="3657600" algn="l" defTabSz="914400" rtl="0" eaLnBrk="1" latinLnBrk="0" hangingPunct="1">
-      <a:defRPr sz="1200" kern="1200">
-        <a:solidFill>
-          <a:schemeClr val="tx1"/>
-        </a:solidFill>
-        <a:latin typeface="+mn-lt"/>
-        <a:ea typeface="+mn-ea"/>
-        <a:cs typeface="+mn-cs"/>
-      </a:defRPr>
-    </a:lvl9pPr>
-  </p:notesStyle>
-</p:notesMaster>
-</file>
-
-<file path=ppt/notesSlides/notesSlide1.xml><?xml version="1.0" encoding="utf-8"?>
-<p:notes xmlns:a="http://schemas.openxmlformats.org/drawingml/2006/main" xmlns:r="http://schemas.openxmlformats.org/officeDocument/2006/relationships" xmlns:p="http://schemas.openxmlformats.org/presentationml/2006/main">
-  <p:cSld>
-    <p:spTree>
-      <p:nvGrpSpPr>
-        <p:cNvPr id="1" name=""/>
-        <p:cNvGrpSpPr/>
-        <p:nvPr/>
-      </p:nvGrpSpPr>
-      <p:grpSpPr>
-        <a:xfrm>
-          <a:off x="0" y="0"/>
-          <a:ext cx="0" cy="0"/>
-          <a:chOff x="0" y="0"/>
-          <a:chExt cx="0" cy="0"/>
-        </a:xfrm>
-      </p:grpSpPr>
-      <p:sp>
-        <p:nvSpPr>
-          <p:cNvPr id="2" name="Slide Image Placeholder 1"/>
-          <p:cNvSpPr>
-            <a:spLocks noGrp="1" noRot="1" noChangeAspect="1"/>
-          </p:cNvSpPr>
-          <p:nvPr>
-            <p:ph type="sldImg"/>
-          </p:nvPr>
-        </p:nvSpPr>
-        <p:spPr/>
-      </p:sp>
-      <p:sp>
-        <p:nvSpPr>
-          <p:cNvPr id="3" name="Notes Placeholder 2"/>
-          <p:cNvSpPr>
-            <a:spLocks noGrp="1"/>
-          </p:cNvSpPr>
-          <p:nvPr>
-            <p:ph type="body" idx="1"/>
-          </p:nvPr>
-        </p:nvSpPr>
-        <p:spPr/>
-        <p:txBody>
-          <a:bodyPr/>
-          <a:lstStyle/>
-          <a:p>
-            <a:r>
-              <a:rPr lang="en-CA" dirty="0"/>
-              <a:t>In 1935, Maurice Bartlett presented the first paper on the topic of interactions in three-way tables. </a:t>
-            </a:r>
-          </a:p>
-          <a:p>
-            <a:r>
-              <a:rPr lang="en-CA" dirty="0"/>
-              <a:t>His main example concerned an agricultural experiment on plum root cuttings …</a:t>
-            </a:r>
-          </a:p>
-        </p:txBody>
-      </p:sp>
-      <p:sp>
-        <p:nvSpPr>
-          <p:cNvPr id="4" name="Slide Number Placeholder 3"/>
-          <p:cNvSpPr>
-            <a:spLocks noGrp="1"/>
-          </p:cNvSpPr>
-          <p:nvPr>
-            <p:ph type="sldNum" sz="quarter" idx="5"/>
-          </p:nvPr>
-        </p:nvSpPr>
-        <p:spPr/>
-        <p:txBody>
-          <a:bodyPr/>
-          <a:lstStyle/>
-          <a:p>
-            <a:fld id="{E94B1ED8-6108-4710-99B1-764EAA2F18C6}" type="slidenum">
-              <a:rPr lang="en-US" smtClean="0"/>
-              <a:t>12</a:t>
-            </a:fld>
-            <a:endParaRPr lang="en-US"/>
-          </a:p>
-        </p:txBody>
-      </p:sp>
-    </p:spTree>
-    <p:extLst>
-      <p:ext uri="{BB962C8B-B14F-4D97-AF65-F5344CB8AC3E}">
-        <p14:creationId xmlns:p14="http://schemas.microsoft.com/office/powerpoint/2010/main" val="498954036"/>
-      </p:ext>
-    </p:extLst>
-  </p:cSld>
-  <p:clrMapOvr>
-    <a:masterClrMapping/>
-  </p:clrMapOvr>
-</p:notes>
-</file>
-
-<file path=ppt/notesSlides/notesSlide2.xml><?xml version="1.0" encoding="utf-8"?>
-<p:notes xmlns:a="http://schemas.openxmlformats.org/drawingml/2006/main" xmlns:r="http://schemas.openxmlformats.org/officeDocument/2006/relationships" xmlns:p="http://schemas.openxmlformats.org/presentationml/2006/main">
-  <p:cSld>
-    <p:spTree>
-      <p:nvGrpSpPr>
-        <p:cNvPr id="1" name=""/>
-        <p:cNvGrpSpPr/>
-        <p:nvPr/>
-      </p:nvGrpSpPr>
-      <p:grpSpPr>
-        <a:xfrm>
-          <a:off x="0" y="0"/>
-          <a:ext cx="0" cy="0"/>
-          <a:chOff x="0" y="0"/>
-          <a:chExt cx="0" cy="0"/>
-        </a:xfrm>
-      </p:grpSpPr>
-      <p:sp>
-        <p:nvSpPr>
-          <p:cNvPr id="2" name="Slide Image Placeholder 1"/>
-          <p:cNvSpPr>
-            <a:spLocks noGrp="1" noRot="1" noChangeAspect="1"/>
-          </p:cNvSpPr>
-          <p:nvPr>
-            <p:ph type="sldImg"/>
-          </p:nvPr>
-        </p:nvSpPr>
-        <p:spPr/>
-      </p:sp>
-      <p:sp>
-        <p:nvSpPr>
-          <p:cNvPr id="3" name="Notes Placeholder 2"/>
-          <p:cNvSpPr>
-            <a:spLocks noGrp="1"/>
-          </p:cNvSpPr>
-          <p:nvPr>
-            <p:ph type="body" idx="1"/>
-          </p:nvPr>
-        </p:nvSpPr>
-        <p:spPr/>
-        <p:txBody>
-          <a:bodyPr/>
-          <a:lstStyle/>
-          <a:p>
-            <a:r>
-              <a:rPr lang="en-CA" dirty="0"/>
-              <a:t>A: for the UCB data, hair-eye color and mental impairment, no margins are fixed -&gt; Poisson</a:t>
-            </a:r>
-          </a:p>
-          <a:p>
-            <a:r>
-              <a:rPr lang="en-CA" dirty="0"/>
-              <a:t>But say we screened 600 males and 600 females, 100 in each department applying to UC Berkeley?</a:t>
-            </a:r>
-          </a:p>
-          <a:p>
-            <a:endParaRPr lang="en-CA" dirty="0"/>
-          </a:p>
-        </p:txBody>
-      </p:sp>
-      <p:sp>
-        <p:nvSpPr>
-          <p:cNvPr id="4" name="Slide Number Placeholder 3"/>
-          <p:cNvSpPr>
-            <a:spLocks noGrp="1"/>
-          </p:cNvSpPr>
-          <p:nvPr>
-            <p:ph type="sldNum" sz="quarter" idx="5"/>
-          </p:nvPr>
-        </p:nvSpPr>
-        <p:spPr/>
-        <p:txBody>
-          <a:bodyPr/>
-          <a:lstStyle/>
-          <a:p>
-            <a:fld id="{E94B1ED8-6108-4710-99B1-764EAA2F18C6}" type="slidenum">
-              <a:rPr lang="en-US" smtClean="0"/>
-              <a:t>22</a:t>
-            </a:fld>
-            <a:endParaRPr lang="en-US"/>
-          </a:p>
-        </p:txBody>
-      </p:sp>
-    </p:spTree>
-    <p:extLst>
-      <p:ext uri="{BB962C8B-B14F-4D97-AF65-F5344CB8AC3E}">
-        <p14:creationId xmlns:p14="http://schemas.microsoft.com/office/powerpoint/2010/main" val="2534160110"/>
-      </p:ext>
-    </p:extLst>
-  </p:cSld>
-  <p:clrMapOvr>
-    <a:masterClrMapping/>
-  </p:clrMapOvr>
-</p:notes>
-</file>
-
-<file path=ppt/notesSlides/notesSlide3.xml><?xml version="1.0" encoding="utf-8"?>
-<p:notes xmlns:a="http://schemas.openxmlformats.org/drawingml/2006/main" xmlns:r="http://schemas.openxmlformats.org/officeDocument/2006/relationships" xmlns:p="http://schemas.openxmlformats.org/presentationml/2006/main">
-  <p:cSld>
-    <p:spTree>
-      <p:nvGrpSpPr>
-        <p:cNvPr id="1" name=""/>
-        <p:cNvGrpSpPr/>
-        <p:nvPr/>
-      </p:nvGrpSpPr>
-      <p:grpSpPr>
-        <a:xfrm>
-          <a:off x="0" y="0"/>
-          <a:ext cx="0" cy="0"/>
-          <a:chOff x="0" y="0"/>
-          <a:chExt cx="0" cy="0"/>
-        </a:xfrm>
-      </p:grpSpPr>
-      <p:sp>
-        <p:nvSpPr>
-          <p:cNvPr id="2" name="Slide Image Placeholder 1"/>
-          <p:cNvSpPr>
-            <a:spLocks noGrp="1" noRot="1" noChangeAspect="1"/>
-          </p:cNvSpPr>
-          <p:nvPr>
-            <p:ph type="sldImg"/>
-          </p:nvPr>
-        </p:nvSpPr>
-        <p:spPr/>
-      </p:sp>
-      <p:sp>
-        <p:nvSpPr>
-          <p:cNvPr id="3" name="Notes Placeholder 2"/>
-          <p:cNvSpPr>
-            <a:spLocks noGrp="1"/>
-          </p:cNvSpPr>
-          <p:nvPr>
-            <p:ph type="body" idx="1"/>
-          </p:nvPr>
-        </p:nvSpPr>
-        <p:spPr/>
-        <p:txBody>
-          <a:bodyPr/>
-          <a:lstStyle/>
-          <a:p>
-            <a:endParaRPr lang="en-CA"/>
-          </a:p>
-        </p:txBody>
-      </p:sp>
-      <p:sp>
-        <p:nvSpPr>
-          <p:cNvPr id="4" name="Slide Number Placeholder 3"/>
-          <p:cNvSpPr>
-            <a:spLocks noGrp="1"/>
-          </p:cNvSpPr>
-          <p:nvPr>
-            <p:ph type="sldNum" sz="quarter" idx="5"/>
-          </p:nvPr>
-        </p:nvSpPr>
-        <p:spPr/>
-        <p:txBody>
-          <a:bodyPr/>
-          <a:lstStyle/>
-          <a:p>
-            <a:fld id="{33E20828-1A1A-4225-BE3A-F8540A5E6146}" type="slidenum">
-              <a:rPr lang="en-US" smtClean="0"/>
-              <a:t>43</a:t>
-            </a:fld>
-            <a:endParaRPr lang="en-US"/>
-          </a:p>
-        </p:txBody>
-      </p:sp>
-    </p:spTree>
-    <p:extLst>
-      <p:ext uri="{BB962C8B-B14F-4D97-AF65-F5344CB8AC3E}">
-        <p14:creationId xmlns:p14="http://schemas.microsoft.com/office/powerpoint/2010/main" val="1127527337"/>
-      </p:ext>
-    </p:extLst>
-  </p:cSld>
-  <p:clrMapOvr>
-    <a:masterClrMapping/>
-  </p:clrMapOvr>
-</p:notes>
-</file>
-
-<file path=ppt/slideLayouts/slideLayout1.xml><?xml version="1.0" encoding="utf-8"?>
+<file path=ppt\slideLayouts\slideLayout1.xml><?xml version="1.0" encoding="utf-8"?>
 <p:sldLayout xmlns:a="http://schemas.openxmlformats.org/drawingml/2006/main" xmlns:r="http://schemas.openxmlformats.org/officeDocument/2006/relationships" xmlns:p="http://schemas.openxmlformats.org/presentationml/2006/main" type="title" preserve="1">
   <p:cSld name="Title Slide">
     <p:spTree>
@@ -1382,7 +1548,7 @@
 </p:sldLayout>
 </file>
 
-<file path=ppt/slideLayouts/slideLayout10.xml><?xml version="1.0" encoding="utf-8"?>
+<file path=ppt\slideLayouts\slideLayout10.xml><?xml version="1.0" encoding="utf-8"?>
 <p:sldLayout xmlns:a="http://schemas.openxmlformats.org/drawingml/2006/main" xmlns:r="http://schemas.openxmlformats.org/officeDocument/2006/relationships" xmlns:p="http://schemas.openxmlformats.org/presentationml/2006/main" type="vertTx" preserve="1">
   <p:cSld name="Title and Vertical Text">
     <p:spTree>
@@ -1550,7 +1716,7 @@
 </p:sldLayout>
 </file>
 
-<file path=ppt/slideLayouts/slideLayout11.xml><?xml version="1.0" encoding="utf-8"?>
+<file path=ppt\slideLayouts\slideLayout11.xml><?xml version="1.0" encoding="utf-8"?>
 <p:sldLayout xmlns:a="http://schemas.openxmlformats.org/drawingml/2006/main" xmlns:r="http://schemas.openxmlformats.org/officeDocument/2006/relationships" xmlns:p="http://schemas.openxmlformats.org/presentationml/2006/main" type="vertTitleAndTx" preserve="1">
   <p:cSld name="Vertical Title and Text">
     <p:spTree>
@@ -1728,7 +1894,7 @@
 </p:sldLayout>
 </file>
 
-<file path=ppt/slideLayouts/slideLayout2.xml><?xml version="1.0" encoding="utf-8"?>
+<file path=ppt\slideLayouts\slideLayout2.xml><?xml version="1.0" encoding="utf-8"?>
 <p:sldLayout xmlns:a="http://schemas.openxmlformats.org/drawingml/2006/main" xmlns:r="http://schemas.openxmlformats.org/officeDocument/2006/relationships" xmlns:p="http://schemas.openxmlformats.org/presentationml/2006/main" type="obj" preserve="1">
   <p:cSld name="Title and Content">
     <p:spTree>
@@ -1913,7 +2079,7 @@
 </p:sldLayout>
 </file>
 
-<file path=ppt/slideLayouts/slideLayout3.xml><?xml version="1.0" encoding="utf-8"?>
+<file path=ppt\slideLayouts\slideLayout3.xml><?xml version="1.0" encoding="utf-8"?>
 <p:sldLayout xmlns:a="http://schemas.openxmlformats.org/drawingml/2006/main" xmlns:r="http://schemas.openxmlformats.org/officeDocument/2006/relationships" xmlns:p="http://schemas.openxmlformats.org/presentationml/2006/main" type="secHead" preserve="1">
   <p:cSld name="Section Header">
     <p:spTree>
@@ -2158,7 +2324,7 @@
 </p:sldLayout>
 </file>
 
-<file path=ppt/slideLayouts/slideLayout4.xml><?xml version="1.0" encoding="utf-8"?>
+<file path=ppt\slideLayouts\slideLayout4.xml><?xml version="1.0" encoding="utf-8"?>
 <p:sldLayout xmlns:a="http://schemas.openxmlformats.org/drawingml/2006/main" xmlns:r="http://schemas.openxmlformats.org/officeDocument/2006/relationships" xmlns:p="http://schemas.openxmlformats.org/presentationml/2006/main" type="twoObj" preserve="1">
   <p:cSld name="Two Content">
     <p:spTree>
@@ -2443,7 +2609,7 @@
 </p:sldLayout>
 </file>
 
-<file path=ppt/slideLayouts/slideLayout5.xml><?xml version="1.0" encoding="utf-8"?>
+<file path=ppt\slideLayouts\slideLayout5.xml><?xml version="1.0" encoding="utf-8"?>
 <p:sldLayout xmlns:a="http://schemas.openxmlformats.org/drawingml/2006/main" xmlns:r="http://schemas.openxmlformats.org/officeDocument/2006/relationships" xmlns:p="http://schemas.openxmlformats.org/presentationml/2006/main" type="twoTxTwoObj" preserve="1">
   <p:cSld name="Comparison">
     <p:spTree>
@@ -2862,7 +3028,7 @@
 </p:sldLayout>
 </file>
 
-<file path=ppt/slideLayouts/slideLayout6.xml><?xml version="1.0" encoding="utf-8"?>
+<file path=ppt\slideLayouts\slideLayout6.xml><?xml version="1.0" encoding="utf-8"?>
 <p:sldLayout xmlns:a="http://schemas.openxmlformats.org/drawingml/2006/main" xmlns:r="http://schemas.openxmlformats.org/officeDocument/2006/relationships" xmlns:p="http://schemas.openxmlformats.org/presentationml/2006/main" type="titleOnly" preserve="1">
   <p:cSld name="Title Only">
     <p:spTree>
@@ -2979,7 +3145,7 @@
 </p:sldLayout>
 </file>
 
-<file path=ppt/slideLayouts/slideLayout7.xml><?xml version="1.0" encoding="utf-8"?>
+<file path=ppt\slideLayouts\slideLayout7.xml><?xml version="1.0" encoding="utf-8"?>
 <p:sldLayout xmlns:a="http://schemas.openxmlformats.org/drawingml/2006/main" xmlns:r="http://schemas.openxmlformats.org/officeDocument/2006/relationships" xmlns:p="http://schemas.openxmlformats.org/presentationml/2006/main" type="blank" preserve="1">
   <p:cSld name="Blank">
     <p:spTree>
@@ -3074,7 +3240,7 @@
 </p:sldLayout>
 </file>
 
-<file path=ppt/slideLayouts/slideLayout8.xml><?xml version="1.0" encoding="utf-8"?>
+<file path=ppt\slideLayouts\slideLayout8.xml><?xml version="1.0" encoding="utf-8"?>
 <p:sldLayout xmlns:a="http://schemas.openxmlformats.org/drawingml/2006/main" xmlns:r="http://schemas.openxmlformats.org/officeDocument/2006/relationships" xmlns:p="http://schemas.openxmlformats.org/presentationml/2006/main" type="objTx" preserve="1">
   <p:cSld name="Content with Caption">
     <p:spTree>
@@ -3349,7 +3515,7 @@
 </p:sldLayout>
 </file>
 
-<file path=ppt/slideLayouts/slideLayout9.xml><?xml version="1.0" encoding="utf-8"?>
+<file path=ppt\slideLayouts\slideLayout9.xml><?xml version="1.0" encoding="utf-8"?>
 <p:sldLayout xmlns:a="http://schemas.openxmlformats.org/drawingml/2006/main" xmlns:r="http://schemas.openxmlformats.org/officeDocument/2006/relationships" xmlns:p="http://schemas.openxmlformats.org/presentationml/2006/main" type="picTx" preserve="1">
   <p:cSld name="Picture with Caption">
     <p:spTree>
@@ -3601,7 +3767,7 @@
 </p:sldLayout>
 </file>
 
-<file path=ppt/slideMasters/slideMaster1.xml><?xml version="1.0" encoding="utf-8"?>
+<file path=ppt\slideMasters\slideMaster1.xml><?xml version="1.0" encoding="utf-8"?>
 <p:sldMaster xmlns:a="http://schemas.openxmlformats.org/drawingml/2006/main" xmlns:r="http://schemas.openxmlformats.org/officeDocument/2006/relationships" xmlns:p="http://schemas.openxmlformats.org/presentationml/2006/main" preserve="1">
   <p:cSld>
     <p:bg>
@@ -4121,7 +4287,7 @@
 </p:sldMaster>
 </file>
 
-<file path=ppt/slides/slide1.xml><?xml version="1.0" encoding="utf-8"?>
+<file path=ppt\slides\slide1.xml><?xml version="1.0" encoding="utf-8"?>
 <p:sld xmlns:a="http://schemas.openxmlformats.org/drawingml/2006/main" xmlns:r="http://schemas.openxmlformats.org/officeDocument/2006/relationships" xmlns:p="http://schemas.openxmlformats.org/presentationml/2006/main">
   <p:cSld>
     <p:bg>
@@ -4427,7 +4593,7 @@
 </p:sld>
 </file>
 
-<file path=ppt/slides/slide10.xml><?xml version="1.0" encoding="utf-8"?>
+<file path=ppt\slides\slide10.xml><?xml version="1.0" encoding="utf-8"?>
 <p:sld xmlns:a="http://schemas.openxmlformats.org/drawingml/2006/main" xmlns:r="http://schemas.openxmlformats.org/officeDocument/2006/relationships" xmlns:p="http://schemas.openxmlformats.org/presentationml/2006/main">
   <p:cSld>
     <p:spTree>
@@ -5217,7 +5383,7 @@
 </p:sld>
 </file>
 
-<file path=ppt/slides/slide11.xml><?xml version="1.0" encoding="utf-8"?>
+<file path=ppt\slides\slide11.xml><?xml version="1.0" encoding="utf-8"?>
 <p:sld xmlns:a="http://schemas.openxmlformats.org/drawingml/2006/main" xmlns:r="http://schemas.openxmlformats.org/officeDocument/2006/relationships" xmlns:p="http://schemas.openxmlformats.org/presentationml/2006/main">
   <p:cSld>
     <p:spTree>
@@ -5730,7 +5896,7 @@
 </p:sld>
 </file>
 
-<file path=ppt/slides/slide12.xml><?xml version="1.0" encoding="utf-8"?>
+<file path=ppt\slides\slide12.xml><?xml version="1.0" encoding="utf-8"?>
 <p:sld xmlns:a="http://schemas.openxmlformats.org/drawingml/2006/main" xmlns:r="http://schemas.openxmlformats.org/officeDocument/2006/relationships" xmlns:p="http://schemas.openxmlformats.org/presentationml/2006/main">
   <p:cSld>
     <p:spTree>
@@ -6506,7 +6672,7 @@
 </p:sld>
 </file>
 
-<file path=ppt/slides/slide13.xml><?xml version="1.0" encoding="utf-8"?>
+<file path=ppt\slides\slide13.xml><?xml version="1.0" encoding="utf-8"?>
 <p:sld xmlns:a="http://schemas.openxmlformats.org/drawingml/2006/main" xmlns:r="http://schemas.openxmlformats.org/officeDocument/2006/relationships" xmlns:p="http://schemas.openxmlformats.org/presentationml/2006/main">
   <p:cSld>
     <p:spTree>
@@ -6820,7 +6986,7 @@
 </p:sld>
 </file>
 
-<file path=ppt/slides/slide14.xml><?xml version="1.0" encoding="utf-8"?>
+<file path=ppt\slides\slide14.xml><?xml version="1.0" encoding="utf-8"?>
 <p:sld xmlns:a="http://schemas.openxmlformats.org/drawingml/2006/main" xmlns:r="http://schemas.openxmlformats.org/officeDocument/2006/relationships" xmlns:p="http://schemas.openxmlformats.org/presentationml/2006/main">
   <p:cSld>
     <p:spTree>
@@ -7116,7 +7282,7 @@
 </p:sld>
 </file>
 
-<file path=ppt/slides/slide15.xml><?xml version="1.0" encoding="utf-8"?>
+<file path=ppt\slides\slide15.xml><?xml version="1.0" encoding="utf-8"?>
 <p:sld xmlns:a="http://schemas.openxmlformats.org/drawingml/2006/main" xmlns:r="http://schemas.openxmlformats.org/officeDocument/2006/relationships" xmlns:p="http://schemas.openxmlformats.org/presentationml/2006/main">
   <p:cSld>
     <p:spTree>
@@ -7747,7 +7913,7 @@
 </p:sld>
 </file>
 
-<file path=ppt/slides/slide16.xml><?xml version="1.0" encoding="utf-8"?>
+<file path=ppt\slides\slide16.xml><?xml version="1.0" encoding="utf-8"?>
 <p:sld xmlns:a="http://schemas.openxmlformats.org/drawingml/2006/main" xmlns:r="http://schemas.openxmlformats.org/officeDocument/2006/relationships" xmlns:p="http://schemas.openxmlformats.org/presentationml/2006/main">
   <p:cSld>
     <p:spTree>
@@ -8505,7 +8671,7 @@
 </p:sld>
 </file>
 
-<file path=ppt/slides/slide17.xml><?xml version="1.0" encoding="utf-8"?>
+<file path=ppt\slides\slide17.xml><?xml version="1.0" encoding="utf-8"?>
 <p:sld xmlns:a="http://schemas.openxmlformats.org/drawingml/2006/main" xmlns:r="http://schemas.openxmlformats.org/officeDocument/2006/relationships" xmlns:p="http://schemas.openxmlformats.org/presentationml/2006/main">
   <p:cSld>
     <p:spTree>
@@ -8878,7 +9044,7 @@
 </p:sld>
 </file>
 
-<file path=ppt/slides/slide18.xml><?xml version="1.0" encoding="utf-8"?>
+<file path=ppt\slides\slide18.xml><?xml version="1.0" encoding="utf-8"?>
 <p:sld xmlns:a="http://schemas.openxmlformats.org/drawingml/2006/main" xmlns:r="http://schemas.openxmlformats.org/officeDocument/2006/relationships" xmlns:p="http://schemas.openxmlformats.org/presentationml/2006/main">
   <p:cSld>
     <p:spTree>
@@ -9622,7 +9788,7 @@
 </p:sld>
 </file>
 
-<file path=ppt/slides/slide19.xml><?xml version="1.0" encoding="utf-8"?>
+<file path=ppt\slides\slide19.xml><?xml version="1.0" encoding="utf-8"?>
 <p:sld xmlns:a="http://schemas.openxmlformats.org/drawingml/2006/main" xmlns:r="http://schemas.openxmlformats.org/officeDocument/2006/relationships" xmlns:p="http://schemas.openxmlformats.org/presentationml/2006/main">
   <p:cSld>
     <p:spTree>
@@ -10542,7 +10708,7 @@
 </p:sld>
 </file>
 
-<file path=ppt/slides/slide2.xml><?xml version="1.0" encoding="utf-8"?>
+<file path=ppt\slides\slide2.xml><?xml version="1.0" encoding="utf-8"?>
 <p:sld xmlns:a="http://schemas.openxmlformats.org/drawingml/2006/main" xmlns:r="http://schemas.openxmlformats.org/officeDocument/2006/relationships" xmlns:p="http://schemas.openxmlformats.org/presentationml/2006/main">
   <p:cSld>
     <p:spTree>
@@ -10726,7 +10892,7 @@
 </p:sld>
 </file>
 
-<file path=ppt/slides/slide20.xml><?xml version="1.0" encoding="utf-8"?>
+<file path=ppt\slides\slide20.xml><?xml version="1.0" encoding="utf-8"?>
 <p:sld xmlns:a="http://schemas.openxmlformats.org/drawingml/2006/main" xmlns:r="http://schemas.openxmlformats.org/officeDocument/2006/relationships" xmlns:p="http://schemas.openxmlformats.org/presentationml/2006/main">
   <p:cSld>
     <p:spTree>
@@ -11371,7 +11537,7 @@
 </p:sld>
 </file>
 
-<file path=ppt/slides/slide21.xml><?xml version="1.0" encoding="utf-8"?>
+<file path=ppt\slides\slide21.xml><?xml version="1.0" encoding="utf-8"?>
 <p:sld xmlns:a="http://schemas.openxmlformats.org/drawingml/2006/main" xmlns:r="http://schemas.openxmlformats.org/officeDocument/2006/relationships" xmlns:p="http://schemas.openxmlformats.org/presentationml/2006/main">
   <p:cSld>
     <p:spTree>
@@ -12030,7 +12196,7 @@
 </p:sld>
 </file>
 
-<file path=ppt/slides/slide22.xml><?xml version="1.0" encoding="utf-8"?>
+<file path=ppt\slides\slide22.xml><?xml version="1.0" encoding="utf-8"?>
 <p:sld xmlns:a="http://schemas.openxmlformats.org/drawingml/2006/main" xmlns:r="http://schemas.openxmlformats.org/officeDocument/2006/relationships" xmlns:p="http://schemas.openxmlformats.org/presentationml/2006/main">
   <p:cSld>
     <p:spTree>
@@ -12610,7 +12776,7 @@
 </p:sld>
 </file>
 
-<file path=ppt/slides/slide23.xml><?xml version="1.0" encoding="utf-8"?>
+<file path=ppt\slides\slide23.xml><?xml version="1.0" encoding="utf-8"?>
 <p:sld xmlns:a="http://schemas.openxmlformats.org/drawingml/2006/main" xmlns:r="http://schemas.openxmlformats.org/officeDocument/2006/relationships" xmlns:p="http://schemas.openxmlformats.org/presentationml/2006/main">
   <p:cSld>
     <p:spTree>
@@ -12951,7 +13117,7 @@
 </p:sld>
 </file>
 
-<file path=ppt/slides/slide24.xml><?xml version="1.0" encoding="utf-8"?>
+<file path=ppt\slides\slide24.xml><?xml version="1.0" encoding="utf-8"?>
 <p:sld xmlns:a="http://schemas.openxmlformats.org/drawingml/2006/main" xmlns:r="http://schemas.openxmlformats.org/officeDocument/2006/relationships" xmlns:p="http://schemas.openxmlformats.org/presentationml/2006/main">
   <p:cSld>
     <p:spTree>
@@ -13120,7 +13286,7 @@
             </a:r>
             <a:r>
               <a:rPr lang="en-US" dirty="0">
-                <a:sym typeface="Symbol MT" panose="05050102010706020507" pitchFamily="18" charset="2"/>
+                <a:sym typeface="Symbol" panose="05050102010706020507" pitchFamily="18" charset="2"/>
               </a:rPr>
               <a:t>  </a:t>
             </a:r>
@@ -13130,20 +13296,20 @@
             </a:r>
             <a:r>
               <a:rPr lang="en-US" dirty="0">
-                <a:sym typeface="Symbol MT" panose="05050102010706020507" pitchFamily="18" charset="2"/>
+                <a:sym typeface="Symbol" panose="05050102010706020507" pitchFamily="18" charset="2"/>
               </a:rPr>
               <a:t>≤  0.8</a:t>
             </a:r>
           </a:p>
           <a:p>
             <a:endParaRPr lang="en-US" dirty="0">
-              <a:sym typeface="Symbol MT" panose="05050102010706020507" pitchFamily="18" charset="2"/>
+              <a:sym typeface="Symbol" panose="05050102010706020507" pitchFamily="18" charset="2"/>
             </a:endParaRPr>
           </a:p>
           <a:p>
             <a:r>
               <a:rPr lang="en-US" dirty="0">
-                <a:sym typeface="Symbol MT" panose="05050102010706020507" pitchFamily="18" charset="2"/>
+                <a:sym typeface="Symbol" panose="05050102010706020507" pitchFamily="18" charset="2"/>
               </a:rPr>
               <a:t>The logit transformation of probability is the basis for </a:t>
             </a:r>
@@ -13152,26 +13318,26 @@
                 <a:solidFill>
                   <a:srgbClr val="0070C0"/>
                 </a:solidFill>
-                <a:sym typeface="Symbol MT" panose="05050102010706020507" pitchFamily="18" charset="2"/>
+                <a:sym typeface="Symbol" panose="05050102010706020507" pitchFamily="18" charset="2"/>
               </a:rPr>
               <a:t>logistic</a:t>
             </a:r>
             <a:r>
               <a:rPr lang="en-US" dirty="0">
-                <a:sym typeface="Symbol MT" panose="05050102010706020507" pitchFamily="18" charset="2"/>
+                <a:sym typeface="Symbol" panose="05050102010706020507" pitchFamily="18" charset="2"/>
               </a:rPr>
               <a:t> regression</a:t>
             </a:r>
           </a:p>
           <a:p>
             <a:endParaRPr lang="en-US" dirty="0">
-              <a:sym typeface="Symbol MT" panose="05050102010706020507" pitchFamily="18" charset="2"/>
+              <a:sym typeface="Symbol" panose="05050102010706020507" pitchFamily="18" charset="2"/>
             </a:endParaRPr>
           </a:p>
           <a:p>
             <a:r>
               <a:rPr lang="en-US" dirty="0">
-                <a:sym typeface="Symbol MT" panose="05050102010706020507" pitchFamily="18" charset="2"/>
+                <a:sym typeface="Symbol" panose="05050102010706020507" pitchFamily="18" charset="2"/>
               </a:rPr>
               <a:t>(An alternative, the cumulative normal, </a:t>
             </a:r>
@@ -13179,31 +13345,31 @@
               <a:rPr lang="el-GR" dirty="0">
                 <a:latin typeface="Calibri" panose="020F0502020204030204" pitchFamily="34" charset="0"/>
                 <a:cs typeface="Calibri" panose="020F0502020204030204" pitchFamily="34" charset="0"/>
-                <a:sym typeface="Symbol MT" panose="05050102010706020507" pitchFamily="18" charset="2"/>
+                <a:sym typeface="Symbol" panose="05050102010706020507" pitchFamily="18" charset="2"/>
               </a:rPr>
               <a:t>Φ</a:t>
             </a:r>
             <a:r>
               <a:rPr lang="en-US" baseline="30000" dirty="0">
-                <a:sym typeface="Symbol MT" panose="05050102010706020507" pitchFamily="18" charset="2"/>
+                <a:sym typeface="Symbol" panose="05050102010706020507" pitchFamily="18" charset="2"/>
               </a:rPr>
               <a:t>-1</a:t>
             </a:r>
             <a:r>
               <a:rPr lang="en-US" dirty="0">
-                <a:sym typeface="Symbol MT" panose="05050102010706020507" pitchFamily="18" charset="2"/>
+                <a:sym typeface="Symbol" panose="05050102010706020507" pitchFamily="18" charset="2"/>
               </a:rPr>
               <a:t>(</a:t>
             </a:r>
             <a:r>
               <a:rPr lang="el-GR" dirty="0">
-                <a:sym typeface="Symbol MT" panose="05050102010706020507" pitchFamily="18" charset="2"/>
+                <a:sym typeface="Symbol" panose="05050102010706020507" pitchFamily="18" charset="2"/>
               </a:rPr>
               <a:t>π</a:t>
             </a:r>
             <a:r>
               <a:rPr lang="en-US" dirty="0">
-                <a:sym typeface="Symbol MT" panose="05050102010706020507" pitchFamily="18" charset="2"/>
+                <a:sym typeface="Symbol" panose="05050102010706020507" pitchFamily="18" charset="2"/>
               </a:rPr>
               <a:t>), gives rise to </a:t>
             </a:r>
@@ -13212,13 +13378,13 @@
                 <a:solidFill>
                   <a:srgbClr val="0070C0"/>
                 </a:solidFill>
-                <a:sym typeface="Symbol MT" panose="05050102010706020507" pitchFamily="18" charset="2"/>
+                <a:sym typeface="Symbol" panose="05050102010706020507" pitchFamily="18" charset="2"/>
               </a:rPr>
               <a:t>probit</a:t>
             </a:r>
             <a:r>
               <a:rPr lang="en-US" dirty="0">
-                <a:sym typeface="Symbol MT" panose="05050102010706020507" pitchFamily="18" charset="2"/>
+                <a:sym typeface="Symbol" panose="05050102010706020507" pitchFamily="18" charset="2"/>
               </a:rPr>
               <a:t> regression)</a:t>
             </a:r>
@@ -13369,7 +13535,7 @@
 </p:sld>
 </file>
 
-<file path=ppt/slides/slide25.xml><?xml version="1.0" encoding="utf-8"?>
+<file path=ppt\slides\slide25.xml><?xml version="1.0" encoding="utf-8"?>
 <p:sld xmlns:a="http://schemas.openxmlformats.org/drawingml/2006/main" xmlns:r="http://schemas.openxmlformats.org/officeDocument/2006/relationships" xmlns:p="http://schemas.openxmlformats.org/presentationml/2006/main">
   <p:cSld>
     <p:spTree>
@@ -13671,7 +13837,7 @@
 </p:sld>
 </file>
 
-<file path=ppt/slides/slide26.xml><?xml version="1.0" encoding="utf-8"?>
+<file path=ppt\slides\slide26.xml><?xml version="1.0" encoding="utf-8"?>
 <p:sld xmlns:a="http://schemas.openxmlformats.org/drawingml/2006/main" xmlns:r="http://schemas.openxmlformats.org/officeDocument/2006/relationships" xmlns:p="http://schemas.openxmlformats.org/presentationml/2006/main">
   <p:cSld>
     <p:spTree>
@@ -14387,7 +14553,7 @@
 </p:sld>
 </file>
 
-<file path=ppt/slides/slide27.xml><?xml version="1.0" encoding="utf-8"?>
+<file path=ppt\slides\slide27.xml><?xml version="1.0" encoding="utf-8"?>
 <p:sld xmlns:a="http://schemas.openxmlformats.org/drawingml/2006/main" xmlns:r="http://schemas.openxmlformats.org/officeDocument/2006/relationships" xmlns:p="http://schemas.openxmlformats.org/presentationml/2006/main">
   <p:cSld>
     <p:spTree>
@@ -14880,7 +15046,7 @@
 </p:sld>
 </file>
 
-<file path=ppt/slides/slide28.xml><?xml version="1.0" encoding="utf-8"?>
+<file path=ppt\slides\slide28.xml><?xml version="1.0" encoding="utf-8"?>
 <p:sld xmlns:a="http://schemas.openxmlformats.org/drawingml/2006/main" xmlns:r="http://schemas.openxmlformats.org/officeDocument/2006/relationships" xmlns:p="http://schemas.openxmlformats.org/presentationml/2006/main">
   <p:cSld>
     <p:spTree>
@@ -15017,7 +15183,7 @@
             </a:r>
             <a:r>
               <a:rPr lang="en-US" dirty="0">
-                <a:sym typeface="Symbol MT" panose="05050102010706020507" pitchFamily="18" charset="2"/>
+                <a:sym typeface="Symbol" panose="05050102010706020507" pitchFamily="18" charset="2"/>
               </a:rPr>
               <a:t>&gt; 5</a:t>
             </a:r>
@@ -15032,19 +15198,19 @@
             </a:pPr>
             <a:r>
               <a:rPr lang="en-US" dirty="0">
-                <a:sym typeface="Symbol MT" panose="05050102010706020507" pitchFamily="18" charset="2"/>
+                <a:sym typeface="Symbol" panose="05050102010706020507" pitchFamily="18" charset="2"/>
               </a:rPr>
               <a:t>Otherwise, use Fisher’s exact test or simulated </a:t>
             </a:r>
             <a:r>
               <a:rPr lang="en-US" i="1" dirty="0">
-                <a:sym typeface="Symbol MT" panose="05050102010706020507" pitchFamily="18" charset="2"/>
+                <a:sym typeface="Symbol" panose="05050102010706020507" pitchFamily="18" charset="2"/>
               </a:rPr>
               <a:t>p-</a:t>
             </a:r>
             <a:r>
               <a:rPr lang="en-US" dirty="0">
-                <a:sym typeface="Symbol MT" panose="05050102010706020507" pitchFamily="18" charset="2"/>
+                <a:sym typeface="Symbol" panose="05050102010706020507" pitchFamily="18" charset="2"/>
               </a:rPr>
               <a:t>values</a:t>
             </a:r>
@@ -15276,7 +15442,7 @@
 </p:sld>
 </file>
 
-<file path=ppt/slides/slide29.xml><?xml version="1.0" encoding="utf-8"?>
+<file path=ppt\slides\slide29.xml><?xml version="1.0" encoding="utf-8"?>
 <p:sld xmlns:a="http://schemas.openxmlformats.org/drawingml/2006/main" xmlns:r="http://schemas.openxmlformats.org/officeDocument/2006/relationships" xmlns:p="http://schemas.openxmlformats.org/presentationml/2006/main">
   <p:cSld>
     <p:spTree>
@@ -15636,7 +15802,7 @@
 </p:sld>
 </file>
 
-<file path=ppt/slides/slide3.xml><?xml version="1.0" encoding="utf-8"?>
+<file path=ppt\slides\slide3.xml><?xml version="1.0" encoding="utf-8"?>
 <p:sld xmlns:a="http://schemas.openxmlformats.org/drawingml/2006/main" xmlns:r="http://schemas.openxmlformats.org/officeDocument/2006/relationships" xmlns:p="http://schemas.openxmlformats.org/presentationml/2006/main">
   <p:cSld>
     <p:spTree>
@@ -16531,7 +16697,7 @@
 </p:sld>
 </file>
 
-<file path=ppt/slides/slide30.xml><?xml version="1.0" encoding="utf-8"?>
+<file path=ppt\slides\slide30.xml><?xml version="1.0" encoding="utf-8"?>
 <p:sld xmlns:a="http://schemas.openxmlformats.org/drawingml/2006/main" xmlns:r="http://schemas.openxmlformats.org/officeDocument/2006/relationships" xmlns:p="http://schemas.openxmlformats.org/presentationml/2006/main">
   <p:cSld>
     <p:spTree>
@@ -16943,7 +17109,7 @@
 </p:sld>
 </file>
 
-<file path=ppt/slides/slide31.xml><?xml version="1.0" encoding="utf-8"?>
+<file path=ppt\slides\slide31.xml><?xml version="1.0" encoding="utf-8"?>
 <p:sld xmlns:a="http://schemas.openxmlformats.org/drawingml/2006/main" xmlns:r="http://schemas.openxmlformats.org/officeDocument/2006/relationships" xmlns:p="http://schemas.openxmlformats.org/presentationml/2006/main">
   <p:cSld>
     <p:spTree>
@@ -17268,7 +17434,7 @@
 </p:sld>
 </file>
 
-<file path=ppt/slides/slide32.xml><?xml version="1.0" encoding="utf-8"?>
+<file path=ppt\slides\slide32.xml><?xml version="1.0" encoding="utf-8"?>
 <p:sld xmlns:a="http://schemas.openxmlformats.org/drawingml/2006/main" xmlns:r="http://schemas.openxmlformats.org/officeDocument/2006/relationships" xmlns:p="http://schemas.openxmlformats.org/presentationml/2006/main">
   <p:cSld>
     <p:spTree>
@@ -17537,7 +17703,7 @@
 </p:sld>
 </file>
 
-<file path=ppt/slides/slide33.xml><?xml version="1.0" encoding="utf-8"?>
+<file path=ppt\slides\slide33.xml><?xml version="1.0" encoding="utf-8"?>
 <p:sld xmlns:a="http://schemas.openxmlformats.org/drawingml/2006/main" xmlns:r="http://schemas.openxmlformats.org/officeDocument/2006/relationships" xmlns:p="http://schemas.openxmlformats.org/presentationml/2006/main">
   <p:cSld>
     <p:spTree>
@@ -17748,7 +17914,7 @@
 </p:sld>
 </file>
 
-<file path=ppt/slides/slide34.xml><?xml version="1.0" encoding="utf-8"?>
+<file path=ppt\slides\slide34.xml><?xml version="1.0" encoding="utf-8"?>
 <p:sld xmlns:a="http://schemas.openxmlformats.org/drawingml/2006/main" xmlns:r="http://schemas.openxmlformats.org/officeDocument/2006/relationships" xmlns:p="http://schemas.openxmlformats.org/presentationml/2006/main">
   <p:cSld>
     <p:spTree>
@@ -17867,7 +18033,7 @@
 </p:sld>
 </file>
 
-<file path=ppt/slides/slide35.xml><?xml version="1.0" encoding="utf-8"?>
+<file path=ppt\slides\slide35.xml><?xml version="1.0" encoding="utf-8"?>
 <p:sld xmlns:a="http://schemas.openxmlformats.org/drawingml/2006/main" xmlns:r="http://schemas.openxmlformats.org/officeDocument/2006/relationships" xmlns:p="http://schemas.openxmlformats.org/presentationml/2006/main">
   <p:cSld>
     <p:spTree>
@@ -17986,7 +18152,7 @@
 </p:sld>
 </file>
 
-<file path=ppt/slides/slide36.xml><?xml version="1.0" encoding="utf-8"?>
+<file path=ppt\slides\slide36.xml><?xml version="1.0" encoding="utf-8"?>
 <p:sld xmlns:a="http://schemas.openxmlformats.org/drawingml/2006/main" xmlns:r="http://schemas.openxmlformats.org/officeDocument/2006/relationships" xmlns:p="http://schemas.openxmlformats.org/presentationml/2006/main">
   <p:cSld>
     <p:spTree>
@@ -18280,7 +18446,7 @@
 </p:sld>
 </file>
 
-<file path=ppt/slides/slide37.xml><?xml version="1.0" encoding="utf-8"?>
+<file path=ppt\slides\slide37.xml><?xml version="1.0" encoding="utf-8"?>
 <p:sld xmlns:a="http://schemas.openxmlformats.org/drawingml/2006/main" xmlns:r="http://schemas.openxmlformats.org/officeDocument/2006/relationships" xmlns:p="http://schemas.openxmlformats.org/presentationml/2006/main">
   <p:cSld>
     <p:spTree>
@@ -18651,7 +18817,7 @@
 </p:sld>
 </file>
 
-<file path=ppt/slides/slide38.xml><?xml version="1.0" encoding="utf-8"?>
+<file path=ppt\slides\slide38.xml><?xml version="1.0" encoding="utf-8"?>
 <p:sld xmlns:a="http://schemas.openxmlformats.org/drawingml/2006/main" xmlns:r="http://schemas.openxmlformats.org/officeDocument/2006/relationships" xmlns:p="http://schemas.openxmlformats.org/presentationml/2006/main">
   <p:cSld>
     <p:spTree>
@@ -18869,7 +19035,7 @@
 </p:sld>
 </file>
 
-<file path=ppt/slides/slide39.xml><?xml version="1.0" encoding="utf-8"?>
+<file path=ppt\slides\slide39.xml><?xml version="1.0" encoding="utf-8"?>
 <p:sld xmlns:a="http://schemas.openxmlformats.org/drawingml/2006/main" xmlns:r="http://schemas.openxmlformats.org/officeDocument/2006/relationships" xmlns:p="http://schemas.openxmlformats.org/presentationml/2006/main">
   <p:cSld>
     <p:spTree>
@@ -19173,7 +19339,7 @@
 </p:sld>
 </file>
 
-<file path=ppt/slides/slide4.xml><?xml version="1.0" encoding="utf-8"?>
+<file path=ppt\slides\slide4.xml><?xml version="1.0" encoding="utf-8"?>
 <p:sld xmlns:a="http://schemas.openxmlformats.org/drawingml/2006/main" xmlns:r="http://schemas.openxmlformats.org/officeDocument/2006/relationships" xmlns:p="http://schemas.openxmlformats.org/presentationml/2006/main">
   <p:cSld>
     <p:spTree>
@@ -19466,7 +19632,7 @@
 </p:sld>
 </file>
 
-<file path=ppt/slides/slide40.xml><?xml version="1.0" encoding="utf-8"?>
+<file path=ppt\slides\slide40.xml><?xml version="1.0" encoding="utf-8"?>
 <p:sld xmlns:a="http://schemas.openxmlformats.org/drawingml/2006/main" xmlns:r="http://schemas.openxmlformats.org/officeDocument/2006/relationships" xmlns:p="http://schemas.openxmlformats.org/presentationml/2006/main">
   <p:cSld>
     <p:spTree>
@@ -20016,7 +20182,7 @@
 </p:sld>
 </file>
 
-<file path=ppt/slides/slide41.xml><?xml version="1.0" encoding="utf-8"?>
+<file path=ppt\slides\slide41.xml><?xml version="1.0" encoding="utf-8"?>
 <p:sld xmlns:a="http://schemas.openxmlformats.org/drawingml/2006/main" xmlns:r="http://schemas.openxmlformats.org/officeDocument/2006/relationships" xmlns:p="http://schemas.openxmlformats.org/presentationml/2006/main">
   <p:cSld>
     <p:spTree>
@@ -20454,7 +20620,7 @@
 </p:sld>
 </file>
 
-<file path=ppt/slides/slide42.xml><?xml version="1.0" encoding="utf-8"?>
+<file path=ppt\slides\slide42.xml><?xml version="1.0" encoding="utf-8"?>
 <p:sld xmlns:a="http://schemas.openxmlformats.org/drawingml/2006/main" xmlns:r="http://schemas.openxmlformats.org/officeDocument/2006/relationships" xmlns:p="http://schemas.openxmlformats.org/presentationml/2006/main">
   <p:cSld>
     <p:spTree>
@@ -20857,7 +21023,7 @@
 </p:sld>
 </file>
 
-<file path=ppt/slides/slide43.xml><?xml version="1.0" encoding="utf-8"?>
+<file path=ppt\slides\slide43.xml><?xml version="1.0" encoding="utf-8"?>
 <p:sld xmlns:a="http://schemas.openxmlformats.org/drawingml/2006/main" xmlns:r="http://schemas.openxmlformats.org/officeDocument/2006/relationships" xmlns:p="http://schemas.openxmlformats.org/presentationml/2006/main">
   <p:cSld>
     <p:spTree>
@@ -21658,7 +21824,7 @@
 </p:sld>
 </file>
 
-<file path=ppt/slides/slide44.xml><?xml version="1.0" encoding="utf-8"?>
+<file path=ppt\slides\slide44.xml><?xml version="1.0" encoding="utf-8"?>
 <p:sld xmlns:a="http://schemas.openxmlformats.org/drawingml/2006/main" xmlns:r="http://schemas.openxmlformats.org/officeDocument/2006/relationships" xmlns:p="http://schemas.openxmlformats.org/presentationml/2006/main">
   <p:cSld>
     <p:spTree>
@@ -21909,7 +22075,7 @@
 </p:sld>
 </file>
 
-<file path=ppt/slides/slide45.xml><?xml version="1.0" encoding="utf-8"?>
+<file path=ppt\slides\slide45.xml><?xml version="1.0" encoding="utf-8"?>
 <p:sld xmlns:a="http://schemas.openxmlformats.org/drawingml/2006/main" xmlns:r="http://schemas.openxmlformats.org/officeDocument/2006/relationships" xmlns:p="http://schemas.openxmlformats.org/presentationml/2006/main">
   <p:cSld>
     <p:spTree>
@@ -22250,7 +22416,7 @@
 </p:sld>
 </file>
 
-<file path=ppt/slides/slide46.xml><?xml version="1.0" encoding="utf-8"?>
+<file path=ppt\slides\slide46.xml><?xml version="1.0" encoding="utf-8"?>
 <p:sld xmlns:a="http://schemas.openxmlformats.org/drawingml/2006/main" xmlns:r="http://schemas.openxmlformats.org/officeDocument/2006/relationships" xmlns:p="http://schemas.openxmlformats.org/presentationml/2006/main">
   <p:cSld>
     <p:spTree>
@@ -22925,7 +23091,7 @@
 </p:sld>
 </file>
 
-<file path=ppt/slides/slide47.xml><?xml version="1.0" encoding="utf-8"?>
+<file path=ppt\slides\slide47.xml><?xml version="1.0" encoding="utf-8"?>
 <p:sld xmlns:a="http://schemas.openxmlformats.org/drawingml/2006/main" xmlns:r="http://schemas.openxmlformats.org/officeDocument/2006/relationships" xmlns:p="http://schemas.openxmlformats.org/presentationml/2006/main">
   <p:cSld>
     <p:spTree>
@@ -23282,7 +23448,7 @@
 </p:sld>
 </file>
 
-<file path=ppt/slides/slide48.xml><?xml version="1.0" encoding="utf-8"?>
+<file path=ppt\slides\slide48.xml><?xml version="1.0" encoding="utf-8"?>
 <p:sld xmlns:a="http://schemas.openxmlformats.org/drawingml/2006/main" xmlns:r="http://schemas.openxmlformats.org/officeDocument/2006/relationships" xmlns:p="http://schemas.openxmlformats.org/presentationml/2006/main">
   <p:cSld>
     <p:spTree>
@@ -23682,7 +23848,7 @@
 </p:sld>
 </file>
 
-<file path=ppt/slides/slide49.xml><?xml version="1.0" encoding="utf-8"?>
+<file path=ppt\slides\slide49.xml><?xml version="1.0" encoding="utf-8"?>
 <p:sld xmlns:a="http://schemas.openxmlformats.org/drawingml/2006/main" xmlns:r="http://schemas.openxmlformats.org/officeDocument/2006/relationships" xmlns:p="http://schemas.openxmlformats.org/presentationml/2006/main">
   <p:cSld>
     <p:spTree>
@@ -24034,7 +24200,7 @@
 </p:sld>
 </file>
 
-<file path=ppt/slides/slide5.xml><?xml version="1.0" encoding="utf-8"?>
+<file path=ppt\slides\slide5.xml><?xml version="1.0" encoding="utf-8"?>
 <p:sld xmlns:a="http://schemas.openxmlformats.org/drawingml/2006/main" xmlns:r="http://schemas.openxmlformats.org/officeDocument/2006/relationships" xmlns:p="http://schemas.openxmlformats.org/presentationml/2006/main">
   <p:cSld>
     <p:spTree>
@@ -24680,7 +24846,7 @@
 </p:sld>
 </file>
 
-<file path=ppt/slides/slide50.xml><?xml version="1.0" encoding="utf-8"?>
+<file path=ppt\slides\slide50.xml><?xml version="1.0" encoding="utf-8"?>
 <p:sld xmlns:a="http://schemas.openxmlformats.org/drawingml/2006/main" xmlns:r="http://schemas.openxmlformats.org/officeDocument/2006/relationships" xmlns:p="http://schemas.openxmlformats.org/presentationml/2006/main">
   <p:cSld>
     <p:spTree>
@@ -24931,7 +25097,7 @@
 </p:sld>
 </file>
 
-<file path=ppt/slides/slide51.xml><?xml version="1.0" encoding="utf-8"?>
+<file path=ppt\slides\slide51.xml><?xml version="1.0" encoding="utf-8"?>
 <p:sld xmlns:a="http://schemas.openxmlformats.org/drawingml/2006/main" xmlns:r="http://schemas.openxmlformats.org/officeDocument/2006/relationships" xmlns:p="http://schemas.openxmlformats.org/presentationml/2006/main">
   <p:cSld>
     <p:spTree>
@@ -25212,7 +25378,7 @@
 </p:sld>
 </file>
 
-<file path=ppt/slides/slide52.xml><?xml version="1.0" encoding="utf-8"?>
+<file path=ppt\slides\slide52.xml><?xml version="1.0" encoding="utf-8"?>
 <p:sld xmlns:a="http://schemas.openxmlformats.org/drawingml/2006/main" xmlns:r="http://schemas.openxmlformats.org/officeDocument/2006/relationships" xmlns:p="http://schemas.openxmlformats.org/presentationml/2006/main">
   <p:cSld>
     <p:spTree>
@@ -25424,7 +25590,7 @@
 </p:sld>
 </file>
 
-<file path=ppt/slides/slide53.xml><?xml version="1.0" encoding="utf-8"?>
+<file path=ppt\slides\slide53.xml><?xml version="1.0" encoding="utf-8"?>
 <p:sld xmlns:a="http://schemas.openxmlformats.org/drawingml/2006/main" xmlns:r="http://schemas.openxmlformats.org/officeDocument/2006/relationships" xmlns:p="http://schemas.openxmlformats.org/presentationml/2006/main">
   <p:cSld>
     <p:spTree>
@@ -25721,7 +25887,7 @@
 </p:sld>
 </file>
 
-<file path=ppt/slides/slide54.xml><?xml version="1.0" encoding="utf-8"?>
+<file path=ppt\slides\slide54.xml><?xml version="1.0" encoding="utf-8"?>
 <p:sld xmlns:a="http://schemas.openxmlformats.org/drawingml/2006/main" xmlns:r="http://schemas.openxmlformats.org/officeDocument/2006/relationships" xmlns:p="http://schemas.openxmlformats.org/presentationml/2006/main">
   <p:cSld>
     <p:spTree>
@@ -26039,7 +26205,7 @@
 </p:sld>
 </file>
 
-<file path=ppt/slides/slide55.xml><?xml version="1.0" encoding="utf-8"?>
+<file path=ppt\slides\slide55.xml><?xml version="1.0" encoding="utf-8"?>
 <p:sld xmlns:a="http://schemas.openxmlformats.org/drawingml/2006/main" xmlns:r="http://schemas.openxmlformats.org/officeDocument/2006/relationships" xmlns:p="http://schemas.openxmlformats.org/presentationml/2006/main">
   <p:cSld>
     <p:spTree>
@@ -26373,7 +26539,7 @@
 </p:sld>
 </file>
 
-<file path=ppt/slides/slide56.xml><?xml version="1.0" encoding="utf-8"?>
+<file path=ppt\slides\slide56.xml><?xml version="1.0" encoding="utf-8"?>
 <p:sld xmlns:a="http://schemas.openxmlformats.org/drawingml/2006/main" xmlns:r="http://schemas.openxmlformats.org/officeDocument/2006/relationships" xmlns:p="http://schemas.openxmlformats.org/presentationml/2006/main">
   <p:cSld>
     <p:spTree>
@@ -26492,7 +26658,7 @@
 </p:sld>
 </file>
 
-<file path=ppt/slides/slide57.xml><?xml version="1.0" encoding="utf-8"?>
+<file path=ppt\slides\slide57.xml><?xml version="1.0" encoding="utf-8"?>
 <p:sld xmlns:a="http://schemas.openxmlformats.org/drawingml/2006/main" xmlns:r="http://schemas.openxmlformats.org/officeDocument/2006/relationships" xmlns:p="http://schemas.openxmlformats.org/presentationml/2006/main">
   <p:cSld>
     <p:spTree>
@@ -26611,7 +26777,7 @@
 </p:sld>
 </file>
 
-<file path=ppt/slides/slide58.xml><?xml version="1.0" encoding="utf-8"?>
+<file path=ppt\slides\slide58.xml><?xml version="1.0" encoding="utf-8"?>
 <p:sld xmlns:a="http://schemas.openxmlformats.org/drawingml/2006/main" xmlns:r="http://schemas.openxmlformats.org/officeDocument/2006/relationships" xmlns:p="http://schemas.openxmlformats.org/presentationml/2006/main">
   <p:cSld>
     <p:spTree>
@@ -26806,7 +26972,7 @@
 </p:sld>
 </file>
 
-<file path=ppt/slides/slide59.xml><?xml version="1.0" encoding="utf-8"?>
+<file path=ppt\slides\slide59.xml><?xml version="1.0" encoding="utf-8"?>
 <p:sld xmlns:a="http://schemas.openxmlformats.org/drawingml/2006/main" xmlns:r="http://schemas.openxmlformats.org/officeDocument/2006/relationships" xmlns:p="http://schemas.openxmlformats.org/presentationml/2006/main">
   <p:cSld>
     <p:spTree>
@@ -27511,7 +27677,7 @@
 </p:sld>
 </file>
 
-<file path=ppt/slides/slide6.xml><?xml version="1.0" encoding="utf-8"?>
+<file path=ppt\slides\slide6.xml><?xml version="1.0" encoding="utf-8"?>
 <p:sld xmlns:a="http://schemas.openxmlformats.org/drawingml/2006/main" xmlns:r="http://schemas.openxmlformats.org/officeDocument/2006/relationships" xmlns:p="http://schemas.openxmlformats.org/presentationml/2006/main">
   <p:cSld>
     <p:spTree>
@@ -27796,7 +27962,7 @@
 </p:sld>
 </file>
 
-<file path=ppt/slides/slide60.xml><?xml version="1.0" encoding="utf-8"?>
+<file path=ppt\slides\slide60.xml><?xml version="1.0" encoding="utf-8"?>
 <p:sld xmlns:a="http://schemas.openxmlformats.org/drawingml/2006/main" xmlns:r="http://schemas.openxmlformats.org/officeDocument/2006/relationships" xmlns:p="http://schemas.openxmlformats.org/presentationml/2006/main">
   <p:cSld>
     <p:spTree>
@@ -28017,7 +28183,7 @@
 </p:sld>
 </file>
 
-<file path=ppt/slides/slide61.xml><?xml version="1.0" encoding="utf-8"?>
+<file path=ppt\slides\slide61.xml><?xml version="1.0" encoding="utf-8"?>
 <p:sld xmlns:a="http://schemas.openxmlformats.org/drawingml/2006/main" xmlns:r="http://schemas.openxmlformats.org/officeDocument/2006/relationships" xmlns:p="http://schemas.openxmlformats.org/presentationml/2006/main">
   <p:cSld>
     <p:spTree>
@@ -28175,7 +28341,7 @@
 </p:sld>
 </file>
 
-<file path=ppt/slides/slide62.xml><?xml version="1.0" encoding="utf-8"?>
+<file path=ppt\slides\slide62.xml><?xml version="1.0" encoding="utf-8"?>
 <p:sld xmlns:a="http://schemas.openxmlformats.org/drawingml/2006/main" xmlns:r="http://schemas.openxmlformats.org/officeDocument/2006/relationships" xmlns:p="http://schemas.openxmlformats.org/presentationml/2006/main">
   <p:cSld>
     <p:spTree>
@@ -28346,7 +28512,7 @@
 </p:sld>
 </file>
 
-<file path=ppt/slides/slide63.xml><?xml version="1.0" encoding="utf-8"?>
+<file path=ppt\slides\slide63.xml><?xml version="1.0" encoding="utf-8"?>
 <p:sld xmlns:a="http://schemas.openxmlformats.org/drawingml/2006/main" xmlns:r="http://schemas.openxmlformats.org/officeDocument/2006/relationships" xmlns:p="http://schemas.openxmlformats.org/presentationml/2006/main">
   <p:cSld>
     <p:spTree>
@@ -29031,7 +29197,7 @@
 </p:sld>
 </file>
 
-<file path=ppt/slides/slide64.xml><?xml version="1.0" encoding="utf-8"?>
+<file path=ppt\slides\slide64.xml><?xml version="1.0" encoding="utf-8"?>
 <p:sld xmlns:a="http://schemas.openxmlformats.org/drawingml/2006/main" xmlns:r="http://schemas.openxmlformats.org/officeDocument/2006/relationships" xmlns:p="http://schemas.openxmlformats.org/presentationml/2006/main">
   <p:cSld>
     <p:spTree>
@@ -29380,7 +29546,7 @@
 </p:sld>
 </file>
 
-<file path=ppt/slides/slide65.xml><?xml version="1.0" encoding="utf-8"?>
+<file path=ppt\slides\slide65.xml><?xml version="1.0" encoding="utf-8"?>
 <p:sld xmlns:a="http://schemas.openxmlformats.org/drawingml/2006/main" xmlns:r="http://schemas.openxmlformats.org/officeDocument/2006/relationships" xmlns:p="http://schemas.openxmlformats.org/presentationml/2006/main">
   <p:cSld>
     <p:spTree>
@@ -29627,7 +29793,7 @@
 </p:sld>
 </file>
 
-<file path=ppt/slides/slide66.xml><?xml version="1.0" encoding="utf-8"?>
+<file path=ppt\slides\slide66.xml><?xml version="1.0" encoding="utf-8"?>
 <p:sld xmlns:a="http://schemas.openxmlformats.org/drawingml/2006/main" xmlns:r="http://schemas.openxmlformats.org/officeDocument/2006/relationships" xmlns:p="http://schemas.openxmlformats.org/presentationml/2006/main">
   <p:cSld>
     <p:spTree>
@@ -29897,7 +30063,7 @@
 </p:sld>
 </file>
 
-<file path=ppt/slides/slide67.xml><?xml version="1.0" encoding="utf-8"?>
+<file path=ppt\slides\slide67.xml><?xml version="1.0" encoding="utf-8"?>
 <p:sld xmlns:a="http://schemas.openxmlformats.org/drawingml/2006/main" xmlns:r="http://schemas.openxmlformats.org/officeDocument/2006/relationships" xmlns:p="http://schemas.openxmlformats.org/presentationml/2006/main">
   <p:cSld>
     <p:spTree>
@@ -30238,7 +30404,7 @@
 </p:sld>
 </file>
 
-<file path=ppt/slides/slide68.xml><?xml version="1.0" encoding="utf-8"?>
+<file path=ppt\slides\slide68.xml><?xml version="1.0" encoding="utf-8"?>
 <p:sld xmlns:a="http://schemas.openxmlformats.org/drawingml/2006/main" xmlns:r="http://schemas.openxmlformats.org/officeDocument/2006/relationships" xmlns:p="http://schemas.openxmlformats.org/presentationml/2006/main">
   <p:cSld>
     <p:spTree>
@@ -30633,7 +30799,7 @@
 </p:sld>
 </file>
 
-<file path=ppt/slides/slide69.xml><?xml version="1.0" encoding="utf-8"?>
+<file path=ppt\slides\slide69.xml><?xml version="1.0" encoding="utf-8"?>
 <p:sld xmlns:a="http://schemas.openxmlformats.org/drawingml/2006/main" xmlns:r="http://schemas.openxmlformats.org/officeDocument/2006/relationships" xmlns:p="http://schemas.openxmlformats.org/presentationml/2006/main">
   <p:cSld>
     <p:spTree>
@@ -30764,7 +30930,7 @@
 </p:sld>
 </file>
 
-<file path=ppt/slides/slide7.xml><?xml version="1.0" encoding="utf-8"?>
+<file path=ppt\slides\slide7.xml><?xml version="1.0" encoding="utf-8"?>
 <p:sld xmlns:a="http://schemas.openxmlformats.org/drawingml/2006/main" xmlns:r="http://schemas.openxmlformats.org/officeDocument/2006/relationships" xmlns:p="http://schemas.openxmlformats.org/presentationml/2006/main">
   <p:cSld>
     <p:spTree>
@@ -31113,7 +31279,7 @@
 </p:sld>
 </file>
 
-<file path=ppt/slides/slide70.xml><?xml version="1.0" encoding="utf-8"?>
+<file path=ppt\slides\slide70.xml><?xml version="1.0" encoding="utf-8"?>
 <p:sld xmlns:a="http://schemas.openxmlformats.org/drawingml/2006/main" xmlns:r="http://schemas.openxmlformats.org/officeDocument/2006/relationships" xmlns:p="http://schemas.openxmlformats.org/presentationml/2006/main">
   <p:cSld>
     <p:spTree>
@@ -31232,7 +31398,7 @@
 </p:sld>
 </file>
 
-<file path=ppt/slides/slide71.xml><?xml version="1.0" encoding="utf-8"?>
+<file path=ppt\slides\slide71.xml><?xml version="1.0" encoding="utf-8"?>
 <p:sld xmlns:a="http://schemas.openxmlformats.org/drawingml/2006/main" xmlns:r="http://schemas.openxmlformats.org/officeDocument/2006/relationships" xmlns:p="http://schemas.openxmlformats.org/presentationml/2006/main">
   <p:cSld>
     <p:spTree>
@@ -31464,7 +31630,7 @@
 </p:sld>
 </file>
 
-<file path=ppt/slides/slide72.xml><?xml version="1.0" encoding="utf-8"?>
+<file path=ppt\slides\slide72.xml><?xml version="1.0" encoding="utf-8"?>
 <p:sld xmlns:a="http://schemas.openxmlformats.org/drawingml/2006/main" xmlns:r="http://schemas.openxmlformats.org/officeDocument/2006/relationships" xmlns:p="http://schemas.openxmlformats.org/presentationml/2006/main">
   <p:cSld>
     <p:spTree>
@@ -31900,7 +32066,7 @@
 </p:sld>
 </file>
 
-<file path=ppt/slides/slide73.xml><?xml version="1.0" encoding="utf-8"?>
+<file path=ppt\slides\slide73.xml><?xml version="1.0" encoding="utf-8"?>
 <p:sld xmlns:a="http://schemas.openxmlformats.org/drawingml/2006/main" xmlns:r="http://schemas.openxmlformats.org/officeDocument/2006/relationships" xmlns:p="http://schemas.openxmlformats.org/presentationml/2006/main">
   <p:cSld>
     <p:spTree>
@@ -33012,7 +33178,7 @@
 </p:sld>
 </file>
 
-<file path=ppt/slides/slide74.xml><?xml version="1.0" encoding="utf-8"?>
+<file path=ppt\slides\slide74.xml><?xml version="1.0" encoding="utf-8"?>
 <p:sld xmlns:a="http://schemas.openxmlformats.org/drawingml/2006/main" xmlns:r="http://schemas.openxmlformats.org/officeDocument/2006/relationships" xmlns:p="http://schemas.openxmlformats.org/presentationml/2006/main">
   <p:cSld>
     <p:spTree>
@@ -33485,13 +33651,13 @@
               <a:rPr lang="en-US" dirty="0">
                 <a:latin typeface="Calibri" panose="020F0502020204030204" pitchFamily="34" charset="0"/>
                 <a:cs typeface="Calibri" panose="020F0502020204030204" pitchFamily="34" charset="0"/>
-                <a:sym typeface="Symbol MT" panose="05050102010706020507" pitchFamily="18" charset="2"/>
+                <a:sym typeface="Symbol" panose="05050102010706020507" pitchFamily="18" charset="2"/>
               </a:rPr>
               <a:t>≡</a:t>
             </a:r>
             <a:r>
               <a:rPr lang="en-US" dirty="0">
-                <a:sym typeface="Symbol MT" panose="05050102010706020507" pitchFamily="18" charset="2"/>
+                <a:sym typeface="Symbol" panose="05050102010706020507" pitchFamily="18" charset="2"/>
               </a:rPr>
               <a:t> A * G</a:t>
             </a:r>
@@ -33538,13 +33704,13 @@
               <a:rPr lang="en-US" dirty="0">
                 <a:latin typeface="Calibri" panose="020F0502020204030204" pitchFamily="34" charset="0"/>
                 <a:cs typeface="Calibri" panose="020F0502020204030204" pitchFamily="34" charset="0"/>
-                <a:sym typeface="Symbol MT" panose="05050102010706020507" pitchFamily="18" charset="2"/>
+                <a:sym typeface="Symbol" panose="05050102010706020507" pitchFamily="18" charset="2"/>
               </a:rPr>
               <a:t>≡ </a:t>
             </a:r>
             <a:r>
               <a:rPr lang="en-US" dirty="0">
-                <a:sym typeface="Symbol MT" panose="05050102010706020507" pitchFamily="18" charset="2"/>
+                <a:sym typeface="Symbol" panose="05050102010706020507" pitchFamily="18" charset="2"/>
               </a:rPr>
               <a:t>A + G</a:t>
             </a:r>
@@ -33869,7 +34035,7 @@
 </p:sld>
 </file>
 
-<file path=ppt/slides/slide75.xml><?xml version="1.0" encoding="utf-8"?>
+<file path=ppt\slides\slide75.xml><?xml version="1.0" encoding="utf-8"?>
 <p:sld xmlns:a="http://schemas.openxmlformats.org/drawingml/2006/main" xmlns:r="http://schemas.openxmlformats.org/officeDocument/2006/relationships" xmlns:p="http://schemas.openxmlformats.org/presentationml/2006/main">
   <p:cSld>
     <p:spTree>
@@ -34094,7 +34260,7 @@
 </p:sld>
 </file>
 
-<file path=ppt/slides/slide76.xml><?xml version="1.0" encoding="utf-8"?>
+<file path=ppt\slides\slide76.xml><?xml version="1.0" encoding="utf-8"?>
 <p:sld xmlns:a="http://schemas.openxmlformats.org/drawingml/2006/main" xmlns:r="http://schemas.openxmlformats.org/officeDocument/2006/relationships" xmlns:p="http://schemas.openxmlformats.org/presentationml/2006/main">
   <p:cSld>
     <p:spTree>
@@ -34692,7 +34858,7 @@
 </p:sld>
 </file>
 
-<file path=ppt/slides/slide8.xml><?xml version="1.0" encoding="utf-8"?>
+<file path=ppt\slides\slide8.xml><?xml version="1.0" encoding="utf-8"?>
 <p:sld xmlns:a="http://schemas.openxmlformats.org/drawingml/2006/main" xmlns:r="http://schemas.openxmlformats.org/officeDocument/2006/relationships" xmlns:p="http://schemas.openxmlformats.org/presentationml/2006/main">
   <p:cSld>
     <p:spTree>
@@ -34969,7 +35135,7 @@
 </p:sld>
 </file>
 
-<file path=ppt/slides/slide9.xml><?xml version="1.0" encoding="utf-8"?>
+<file path=ppt\slides\slide9.xml><?xml version="1.0" encoding="utf-8"?>
 <p:sld xmlns:a="http://schemas.openxmlformats.org/drawingml/2006/main" xmlns:r="http://schemas.openxmlformats.org/officeDocument/2006/relationships" xmlns:p="http://schemas.openxmlformats.org/presentationml/2006/main">
   <p:cSld>
     <p:spTree>
@@ -35873,7 +36039,189 @@
 </p:sld>
 </file>
 
-<file path=ppt/theme/theme1.xml><?xml version="1.0" encoding="utf-8"?>
+<file path=ppt\tableStyles.xml><?xml version="1.0" encoding="utf-8"?>
+<a:tblStyleLst xmlns:a="http://schemas.openxmlformats.org/drawingml/2006/main" def="{5C22544A-7EE6-4342-B048-85BDC9FD1C3A}">
+  <a:tblStyle styleId="{5C22544A-7EE6-4342-B048-85BDC9FD1C3A}" styleName="Medium Style 2 - Accent 1">
+    <a:wholeTbl>
+      <a:tcTxStyle>
+        <a:fontRef idx="minor">
+          <a:prstClr val="black"/>
+        </a:fontRef>
+        <a:schemeClr val="dk1"/>
+      </a:tcTxStyle>
+      <a:tcStyle>
+        <a:tcBdr>
+          <a:left>
+            <a:ln w="12700" cmpd="sng">
+              <a:solidFill>
+                <a:schemeClr val="lt1"/>
+              </a:solidFill>
+            </a:ln>
+          </a:left>
+          <a:right>
+            <a:ln w="12700" cmpd="sng">
+              <a:solidFill>
+                <a:schemeClr val="lt1"/>
+              </a:solidFill>
+            </a:ln>
+          </a:right>
+          <a:top>
+            <a:ln w="12700" cmpd="sng">
+              <a:solidFill>
+                <a:schemeClr val="lt1"/>
+              </a:solidFill>
+            </a:ln>
+          </a:top>
+          <a:bottom>
+            <a:ln w="12700" cmpd="sng">
+              <a:solidFill>
+                <a:schemeClr val="lt1"/>
+              </a:solidFill>
+            </a:ln>
+          </a:bottom>
+          <a:insideH>
+            <a:ln w="12700" cmpd="sng">
+              <a:solidFill>
+                <a:schemeClr val="lt1"/>
+              </a:solidFill>
+            </a:ln>
+          </a:insideH>
+          <a:insideV>
+            <a:ln w="12700" cmpd="sng">
+              <a:solidFill>
+                <a:schemeClr val="lt1"/>
+              </a:solidFill>
+            </a:ln>
+          </a:insideV>
+        </a:tcBdr>
+        <a:fill>
+          <a:solidFill>
+            <a:schemeClr val="accent1">
+              <a:tint val="20000"/>
+            </a:schemeClr>
+          </a:solidFill>
+        </a:fill>
+      </a:tcStyle>
+    </a:wholeTbl>
+    <a:band1H>
+      <a:tcStyle>
+        <a:tcBdr/>
+        <a:fill>
+          <a:solidFill>
+            <a:schemeClr val="accent1">
+              <a:tint val="40000"/>
+            </a:schemeClr>
+          </a:solidFill>
+        </a:fill>
+      </a:tcStyle>
+    </a:band1H>
+    <a:band2H>
+      <a:tcStyle>
+        <a:tcBdr/>
+      </a:tcStyle>
+    </a:band2H>
+    <a:band1V>
+      <a:tcStyle>
+        <a:tcBdr/>
+        <a:fill>
+          <a:solidFill>
+            <a:schemeClr val="accent1">
+              <a:tint val="40000"/>
+            </a:schemeClr>
+          </a:solidFill>
+        </a:fill>
+      </a:tcStyle>
+    </a:band1V>
+    <a:band2V>
+      <a:tcStyle>
+        <a:tcBdr/>
+      </a:tcStyle>
+    </a:band2V>
+    <a:lastCol>
+      <a:tcTxStyle b="on">
+        <a:fontRef idx="minor">
+          <a:prstClr val="black"/>
+        </a:fontRef>
+        <a:schemeClr val="lt1"/>
+      </a:tcTxStyle>
+      <a:tcStyle>
+        <a:tcBdr/>
+        <a:fill>
+          <a:solidFill>
+            <a:schemeClr val="accent1"/>
+          </a:solidFill>
+        </a:fill>
+      </a:tcStyle>
+    </a:lastCol>
+    <a:firstCol>
+      <a:tcTxStyle b="on">
+        <a:fontRef idx="minor">
+          <a:prstClr val="black"/>
+        </a:fontRef>
+        <a:schemeClr val="lt1"/>
+      </a:tcTxStyle>
+      <a:tcStyle>
+        <a:tcBdr/>
+        <a:fill>
+          <a:solidFill>
+            <a:schemeClr val="accent1"/>
+          </a:solidFill>
+        </a:fill>
+      </a:tcStyle>
+    </a:firstCol>
+    <a:lastRow>
+      <a:tcTxStyle b="on">
+        <a:fontRef idx="minor">
+          <a:prstClr val="black"/>
+        </a:fontRef>
+        <a:schemeClr val="lt1"/>
+      </a:tcTxStyle>
+      <a:tcStyle>
+        <a:tcBdr>
+          <a:top>
+            <a:ln w="38100" cmpd="sng">
+              <a:solidFill>
+                <a:schemeClr val="lt1"/>
+              </a:solidFill>
+            </a:ln>
+          </a:top>
+        </a:tcBdr>
+        <a:fill>
+          <a:solidFill>
+            <a:schemeClr val="accent1"/>
+          </a:solidFill>
+        </a:fill>
+      </a:tcStyle>
+    </a:lastRow>
+    <a:firstRow>
+      <a:tcTxStyle b="on">
+        <a:fontRef idx="minor">
+          <a:prstClr val="black"/>
+        </a:fontRef>
+        <a:schemeClr val="lt1"/>
+      </a:tcTxStyle>
+      <a:tcStyle>
+        <a:tcBdr>
+          <a:bottom>
+            <a:ln w="38100" cmpd="sng">
+              <a:solidFill>
+                <a:schemeClr val="lt1"/>
+              </a:solidFill>
+            </a:ln>
+          </a:bottom>
+        </a:tcBdr>
+        <a:fill>
+          <a:solidFill>
+            <a:schemeClr val="accent1"/>
+          </a:solidFill>
+        </a:fill>
+      </a:tcStyle>
+    </a:firstRow>
+  </a:tblStyle>
+</a:tblStyleLst>
+</file>
+
+<file path=ppt\theme\theme1.xml><?xml version="1.0" encoding="utf-8"?>
 <a:theme xmlns:a="http://schemas.openxmlformats.org/drawingml/2006/main" name="1_Office Theme">
   <a:themeElements>
     <a:clrScheme name="Office">
@@ -36158,7 +36506,7 @@
 </a:theme>
 </file>
 
-<file path=ppt/theme/theme2.xml><?xml version="1.0" encoding="utf-8"?>
+<file path=ppt\theme\theme2.xml><?xml version="1.0" encoding="utf-8"?>
 <a:theme xmlns:a="http://schemas.openxmlformats.org/drawingml/2006/main" name="Office Theme">
   <a:themeElements>
     <a:clrScheme name="Office">
@@ -36453,7 +36801,7 @@
 </a:theme>
 </file>
 
-<file path=ppt/theme/theme3.xml><?xml version="1.0" encoding="utf-8"?>
+<file path=ppt\theme\theme3.xml><?xml version="1.0" encoding="utf-8"?>
 <a:theme xmlns:a="http://schemas.openxmlformats.org/drawingml/2006/main" name="Office Theme">
   <a:themeElements>
     <a:clrScheme name="Office">
@@ -36736,4 +37084,62 @@
   <a:objectDefaults/>
   <a:extraClrSchemeLst/>
 </a:theme>
+</file>
+
+<file path=ppt\viewProps.xml><?xml version="1.0" encoding="utf-8"?>
+<p:viewPr xmlns:a="http://schemas.openxmlformats.org/drawingml/2006/main" xmlns:r="http://schemas.openxmlformats.org/officeDocument/2006/relationships" xmlns:p="http://schemas.openxmlformats.org/presentationml/2006/main">
+  <p:normalViewPr>
+    <p:restoredLeft sz="15620"/>
+    <p:restoredTop sz="94660"/>
+  </p:normalViewPr>
+  <p:slideViewPr>
+    <p:cSldViewPr>
+      <p:cViewPr varScale="1">
+        <p:scale>
+          <a:sx n="102" d="100"/>
+          <a:sy n="102" d="100"/>
+        </p:scale>
+        <p:origin x="1086" y="102"/>
+      </p:cViewPr>
+      <p:guideLst>
+        <p:guide orient="horz" pos="2160"/>
+        <p:guide pos="2880"/>
+      </p:guideLst>
+    </p:cSldViewPr>
+  </p:slideViewPr>
+  <p:notesTextViewPr>
+    <p:cViewPr>
+      <p:scale>
+        <a:sx n="1" d="1"/>
+        <a:sy n="1" d="1"/>
+      </p:scale>
+      <p:origin x="0" y="0"/>
+    </p:cViewPr>
+  </p:notesTextViewPr>
+  <p:sorterViewPr>
+    <p:cViewPr>
+      <p:scale>
+        <a:sx n="100" d="100"/>
+        <a:sy n="100" d="100"/>
+      </p:scale>
+      <p:origin x="0" y="-1398"/>
+    </p:cViewPr>
+  </p:sorterViewPr>
+  <p:notesViewPr>
+    <p:cSldViewPr>
+      <p:cViewPr varScale="1">
+        <p:scale>
+          <a:sx n="87" d="100"/>
+          <a:sy n="87" d="100"/>
+        </p:scale>
+        <p:origin x="-2040" y="-72"/>
+      </p:cViewPr>
+      <p:guideLst>
+        <p:guide orient="horz" pos="2880"/>
+        <p:guide pos="2160"/>
+      </p:guideLst>
+    </p:cSldViewPr>
+  </p:notesViewPr>
+  <p:gridSpacing cx="76200" cy="76200"/>
+</p:viewPr>
 </file>
</xml_diff>